<commit_message>
Rewrite rival AI flowchart slides for audience readability
- Rewrote all labels as plain English questions ("Am I hungry?")
- Added numbered STEP labels on the flowchart for guided reading
- Added dedicated "WHAT IS delta?" explainer box (frame-rate
  independence: delta = seconds since last frame, ~0.016s at 60fps)
- Rewrote every inline code comment in plain English
- Added subtitle descriptions under each code section
- Expanded the summary slide KEY CONCEPTS box with both
  hunger and delta explanations
- Overwritten existing .pptx file

https://claude.ai/code/session_01R4qTjTPxaHLRUXpJNsyzyr
</commit_message>
<xml_diff>
--- a/docs/Rival_AI_Flowchart.pptx
+++ b/docs/Rival_AI_Flowchart.pptx
@@ -3106,7 +3106,7 @@
         </p:nvSpPr>
         <p:spPr>
           <a:xfrm>
-            <a:off x="457200" y="182880"/>
+            <a:off x="457200" y="137160"/>
             <a:ext cx="10972800" cy="457200"/>
           </a:xfrm>
           <a:prstGeom prst="rect">
@@ -3128,7 +3128,7 @@
                 </a:solidFill>
                 <a:latin typeface="Consolas"/>
               </a:rPr>
-              <a:t>Rival Microbe AI — Decision Flowchart</a:t>
+              <a:t>Rival Microbe AI — How It Decides What To Do</a:t>
             </a:r>
           </a:p>
         </p:txBody>
@@ -3141,7 +3141,7 @@
         </p:nvSpPr>
         <p:spPr>
           <a:xfrm>
-            <a:off x="457200" y="640080"/>
+            <a:off x="457200" y="566928"/>
             <a:ext cx="10972800" cy="320040"/>
           </a:xfrm>
           <a:prstGeom prst="rect">
@@ -3159,25 +3159,60 @@
             <a:r>
               <a:rPr sz="1400" b="0">
                 <a:solidFill>
-                  <a:srgbClr val="888899"/>
-                </a:solidFill>
-                <a:latin typeface="Consolas"/>
-              </a:rPr>
-              <a:t>rival.gd  →  do_move()  called every 0.4 seconds</a:t>
-            </a:r>
-          </a:p>
-        </p:txBody>
-      </p:sp>
-      <p:sp>
-        <p:nvSpPr>
-          <p:cNvPr id="4" name="Rounded Rectangle 3"/>
+                  <a:srgbClr val="AAAABB"/>
+                </a:solidFill>
+                <a:latin typeface="Consolas"/>
+              </a:rPr>
+              <a:t>Every 0.4 seconds, the rival asks itself: "What should I do next?"</a:t>
+            </a:r>
+          </a:p>
+        </p:txBody>
+      </p:sp>
+      <p:sp>
+        <p:nvSpPr>
+          <p:cNvPr id="4" name="TextBox 3"/>
+          <p:cNvSpPr txBox="1"/>
+          <p:nvPr/>
+        </p:nvSpPr>
+        <p:spPr>
+          <a:xfrm>
+            <a:off x="137160" y="1097280"/>
+            <a:ext cx="822960" cy="320040"/>
+          </a:xfrm>
+          <a:prstGeom prst="rect">
+            <a:avLst/>
+          </a:prstGeom>
+          <a:noFill/>
+        </p:spPr>
+        <p:txBody>
+          <a:bodyPr wrap="square">
+            <a:spAutoFit/>
+          </a:bodyPr>
+          <a:lstStyle/>
+          <a:p>
+            <a:pPr algn="ctr"/>
+            <a:r>
+              <a:rPr sz="900" b="1">
+                <a:solidFill>
+                  <a:srgbClr val="FFD700"/>
+                </a:solidFill>
+                <a:latin typeface="Consolas"/>
+              </a:rPr>
+              <a:t>STEP 1</a:t>
+            </a:r>
+          </a:p>
+        </p:txBody>
+      </p:sp>
+      <p:sp>
+        <p:nvSpPr>
+          <p:cNvPr id="5" name="Rounded Rectangle 4"/>
           <p:cNvSpPr/>
           <p:nvPr/>
         </p:nvSpPr>
         <p:spPr>
           <a:xfrm>
-            <a:off x="4389120" y="1097280"/>
-            <a:ext cx="1828800" cy="502920"/>
+            <a:off x="4206240" y="1051560"/>
+            <a:ext cx="2194560" cy="548640"/>
           </a:xfrm>
           <a:prstGeom prst="roundRect">
             <a:avLst/>
@@ -3210,29 +3245,49 @@
           <a:bodyPr rtlCol="0" anchor="ctr" wrap="square"/>
           <a:lstStyle/>
           <a:p>
-            <a:pPr algn="ctr"/>
-            <a:r>
-              <a:rPr sz="1400" b="1">
+            <a:pPr algn="ctr">
+              <a:spcAft>
+                <a:spcPts val="200"/>
+              </a:spcAft>
+            </a:pPr>
+            <a:r>
+              <a:rPr sz="1300" b="1">
                 <a:solidFill>
                   <a:srgbClr val="FFFFFF"/>
                 </a:solidFill>
                 <a:latin typeface="Consolas"/>
               </a:rPr>
-              <a:t>do_move()</a:t>
+              <a:t>Timer fires</a:t>
+            </a:r>
+          </a:p>
+          <a:p>
+            <a:pPr algn="ctr">
+              <a:spcAft>
+                <a:spcPts val="200"/>
+              </a:spcAft>
+            </a:pPr>
+            <a:r>
+              <a:rPr sz="900" b="0">
+                <a:solidFill>
+                  <a:srgbClr val="AAAABB"/>
+                </a:solidFill>
+                <a:latin typeface="Consolas"/>
+              </a:rPr>
+              <a:t>do_move() is called</a:t>
             </a:r>
           </a:p>
         </p:txBody>
       </p:sp>
       <p:cxnSp>
         <p:nvCxnSpPr>
-          <p:cNvPr id="5" name="Connector 4"/>
+          <p:cNvPr id="6" name="Connector 5"/>
           <p:cNvCxnSpPr/>
           <p:nvPr/>
         </p:nvCxnSpPr>
         <p:spPr>
           <a:xfrm>
             <a:off x="5303520" y="1600200"/>
-            <a:ext cx="0" cy="320040"/>
+            <a:ext cx="0" cy="228600"/>
           </a:xfrm>
           <a:prstGeom prst="line">
             <a:avLst/>
@@ -3260,14 +3315,49 @@
       </p:cxnSp>
       <p:sp>
         <p:nvSpPr>
-          <p:cNvPr id="6" name="Rounded Rectangle 5"/>
+          <p:cNvPr id="7" name="TextBox 6"/>
+          <p:cNvSpPr txBox="1"/>
+          <p:nvPr/>
+        </p:nvSpPr>
+        <p:spPr>
+          <a:xfrm>
+            <a:off x="137160" y="1874520"/>
+            <a:ext cx="822960" cy="320040"/>
+          </a:xfrm>
+          <a:prstGeom prst="rect">
+            <a:avLst/>
+          </a:prstGeom>
+          <a:noFill/>
+        </p:spPr>
+        <p:txBody>
+          <a:bodyPr wrap="square">
+            <a:spAutoFit/>
+          </a:bodyPr>
+          <a:lstStyle/>
+          <a:p>
+            <a:pPr algn="ctr"/>
+            <a:r>
+              <a:rPr sz="900" b="1">
+                <a:solidFill>
+                  <a:srgbClr val="FFD700"/>
+                </a:solidFill>
+                <a:latin typeface="Consolas"/>
+              </a:rPr>
+              <a:t>STEP 2</a:t>
+            </a:r>
+          </a:p>
+        </p:txBody>
+      </p:sp>
+      <p:sp>
+        <p:nvSpPr>
+          <p:cNvPr id="8" name="Rounded Rectangle 7"/>
           <p:cNvSpPr/>
           <p:nvPr/>
         </p:nvSpPr>
         <p:spPr>
           <a:xfrm>
-            <a:off x="4114800" y="1920240"/>
-            <a:ext cx="2377440" cy="548640"/>
+            <a:off x="3931920" y="1828800"/>
+            <a:ext cx="2743200" cy="594360"/>
           </a:xfrm>
           <a:prstGeom prst="roundRect">
             <a:avLst/>
@@ -3308,11 +3398,11 @@
             <a:r>
               <a:rPr sz="1200" b="1">
                 <a:solidFill>
-                  <a:srgbClr val="50B0C0"/>
-                </a:solidFill>
-                <a:latin typeface="Consolas"/>
-              </a:rPr>
-              <a:t>var roll = randf()</a:t>
+                  <a:srgbClr val="FFFFFF"/>
+                </a:solidFill>
+                <a:latin typeface="Consolas"/>
+              </a:rPr>
+              <a:t>Roll a random number 0–100%</a:t>
             </a:r>
           </a:p>
           <a:p>
@@ -3322,27 +3412,27 @@
               </a:spcAft>
             </a:pPr>
             <a:r>
-              <a:rPr sz="1000" b="0">
-                <a:solidFill>
-                  <a:srgbClr val="888899"/>
-                </a:solidFill>
-                <a:latin typeface="Consolas"/>
-              </a:rPr>
-              <a:t>Random 0.0 — 1.0</a:t>
+              <a:rPr sz="900" b="0">
+                <a:solidFill>
+                  <a:srgbClr val="AAAABB"/>
+                </a:solidFill>
+                <a:latin typeface="Consolas"/>
+              </a:rPr>
+              <a:t>var roll = randf()  — like rolling a die</a:t>
             </a:r>
           </a:p>
         </p:txBody>
       </p:sp>
       <p:cxnSp>
         <p:nvCxnSpPr>
-          <p:cNvPr id="7" name="Connector 6"/>
+          <p:cNvPr id="9" name="Connector 8"/>
           <p:cNvCxnSpPr/>
           <p:nvPr/>
         </p:nvCxnSpPr>
         <p:spPr>
           <a:xfrm>
-            <a:off x="5303520" y="2468880"/>
-            <a:ext cx="0" cy="457200"/>
+            <a:off x="5303520" y="2423160"/>
+            <a:ext cx="0" cy="365760"/>
           </a:xfrm>
           <a:prstGeom prst="line">
             <a:avLst/>
@@ -3370,13 +3460,48 @@
       </p:cxnSp>
       <p:sp>
         <p:nvSpPr>
-          <p:cNvPr id="8" name="Diamond 7"/>
+          <p:cNvPr id="10" name="TextBox 9"/>
+          <p:cNvSpPr txBox="1"/>
+          <p:nvPr/>
+        </p:nvSpPr>
+        <p:spPr>
+          <a:xfrm>
+            <a:off x="137160" y="2926080"/>
+            <a:ext cx="822960" cy="320040"/>
+          </a:xfrm>
+          <a:prstGeom prst="rect">
+            <a:avLst/>
+          </a:prstGeom>
+          <a:noFill/>
+        </p:spPr>
+        <p:txBody>
+          <a:bodyPr wrap="square">
+            <a:spAutoFit/>
+          </a:bodyPr>
+          <a:lstStyle/>
+          <a:p>
+            <a:pPr algn="ctr"/>
+            <a:r>
+              <a:rPr sz="900" b="1">
+                <a:solidFill>
+                  <a:srgbClr val="FFD700"/>
+                </a:solidFill>
+                <a:latin typeface="Consolas"/>
+              </a:rPr>
+              <a:t>STEP 3</a:t>
+            </a:r>
+          </a:p>
+        </p:txBody>
+      </p:sp>
+      <p:sp>
+        <p:nvSpPr>
+          <p:cNvPr id="11" name="Diamond 10"/>
           <p:cNvSpPr/>
           <p:nvPr/>
         </p:nvSpPr>
         <p:spPr>
           <a:xfrm>
-            <a:off x="4023360" y="2926080"/>
+            <a:off x="4023360" y="2788920"/>
             <a:ext cx="2560320" cy="914400"/>
           </a:xfrm>
           <a:prstGeom prst="diamond">
@@ -3416,13 +3541,13 @@
               </a:spcAft>
             </a:pPr>
             <a:r>
-              <a:rPr sz="1100" b="1">
+              <a:rPr sz="1200" b="1">
                 <a:solidFill>
                   <a:srgbClr val="4FDF6F"/>
                 </a:solidFill>
                 <a:latin typeface="Consolas"/>
               </a:rPr>
-              <a:t>roll &lt; 45-75%?</a:t>
+              <a:t>Am I hungry?</a:t>
             </a:r>
           </a:p>
           <a:p>
@@ -3434,24 +3559,40 @@
             <a:r>
               <a:rPr sz="900" b="0">
                 <a:solidFill>
-                  <a:srgbClr val="888899"/>
-                </a:solidFill>
-                <a:latin typeface="Consolas"/>
-              </a:rPr>
-              <a:t>(seek_chance)</a:t>
+                  <a:srgbClr val="AAAABB"/>
+                </a:solidFill>
+                <a:latin typeface="Consolas"/>
+              </a:rPr>
+              <a:t>roll &lt; seek_chance</a:t>
+            </a:r>
+          </a:p>
+          <a:p>
+            <a:pPr algn="ctr">
+              <a:spcAft>
+                <a:spcPts val="200"/>
+              </a:spcAft>
+            </a:pPr>
+            <a:r>
+              <a:rPr sz="900" b="0">
+                <a:solidFill>
+                  <a:srgbClr val="AAAABB"/>
+                </a:solidFill>
+                <a:latin typeface="Consolas"/>
+              </a:rPr>
+              <a:t>(45% to 75%)</a:t>
             </a:r>
           </a:p>
         </p:txBody>
       </p:sp>
       <p:cxnSp>
         <p:nvCxnSpPr>
-          <p:cNvPr id="9" name="Connector 8"/>
+          <p:cNvPr id="12" name="Connector 11"/>
           <p:cNvCxnSpPr/>
           <p:nvPr/>
         </p:nvCxnSpPr>
         <p:spPr>
           <a:xfrm flipH="1">
-            <a:off x="3474720" y="3383280"/>
+            <a:off x="3474720" y="3246120"/>
             <a:ext cx="548640" cy="0"/>
           </a:xfrm>
           <a:prstGeom prst="line">
@@ -3480,14 +3621,14 @@
       </p:cxnSp>
       <p:sp>
         <p:nvSpPr>
-          <p:cNvPr id="10" name="Rounded Rectangle 9"/>
+          <p:cNvPr id="13" name="Rounded Rectangle 12"/>
           <p:cNvSpPr/>
           <p:nvPr/>
         </p:nvSpPr>
         <p:spPr>
           <a:xfrm>
-            <a:off x="1097280" y="2880360"/>
-            <a:ext cx="2377440" cy="1005840"/>
+            <a:off x="914400" y="2651760"/>
+            <a:ext cx="2560320" cy="1188720"/>
           </a:xfrm>
           <a:prstGeom prst="roundRect">
             <a:avLst/>
@@ -3526,7 +3667,7 @@
               </a:spcAft>
             </a:pPr>
             <a:r>
-              <a:rPr sz="1400" b="1">
+              <a:rPr sz="1500" b="1">
                 <a:solidFill>
                   <a:srgbClr val="4FDF6F"/>
                 </a:solidFill>
@@ -3542,13 +3683,29 @@
               </a:spcAft>
             </a:pPr>
             <a:r>
+              <a:rPr sz="400" b="0">
+                <a:solidFill>
+                  <a:srgbClr val="4FDF6F"/>
+                </a:solidFill>
+                <a:latin typeface="Consolas"/>
+              </a:rPr>
+              <a:t/>
+            </a:r>
+          </a:p>
+          <a:p>
+            <a:pPr algn="ctr">
+              <a:spcAft>
+                <a:spcPts val="200"/>
+              </a:spcAft>
+            </a:pPr>
+            <a:r>
               <a:rPr sz="1000" b="0">
                 <a:solidFill>
-                  <a:srgbClr val="50B0C0"/>
-                </a:solidFill>
-                <a:latin typeface="Consolas"/>
-              </a:rPr>
-              <a:t>_seek_substrate()</a:t>
+                  <a:srgbClr val="FFFFFF"/>
+                </a:solidFill>
+                <a:latin typeface="Consolas"/>
+              </a:rPr>
+              <a:t>Look around for the nearest</a:t>
             </a:r>
           </a:p>
           <a:p>
@@ -3558,13 +3715,13 @@
               </a:spcAft>
             </a:pPr>
             <a:r>
-              <a:rPr sz="900" b="0">
-                <a:solidFill>
-                  <a:srgbClr val="888899"/>
-                </a:solidFill>
-                <a:latin typeface="Consolas"/>
-              </a:rPr>
-              <a:t>Find nearest substrate</a:t>
+              <a:rPr sz="1000" b="0">
+                <a:solidFill>
+                  <a:srgbClr val="FFFFFF"/>
+                </a:solidFill>
+                <a:latin typeface="Consolas"/>
+              </a:rPr>
+              <a:t>food (substrate) within</a:t>
             </a:r>
           </a:p>
           <a:p>
@@ -3574,13 +3731,13 @@
               </a:spcAft>
             </a:pPr>
             <a:r>
-              <a:rPr sz="900" b="0">
-                <a:solidFill>
-                  <a:srgbClr val="888899"/>
-                </a:solidFill>
-                <a:latin typeface="Consolas"/>
-              </a:rPr>
-              <a:t>within 12 tiles</a:t>
+              <a:rPr sz="1000" b="0">
+                <a:solidFill>
+                  <a:srgbClr val="FFFFFF"/>
+                </a:solidFill>
+                <a:latin typeface="Consolas"/>
+              </a:rPr>
+              <a:t>12 tiles — then move</a:t>
             </a:r>
           </a:p>
           <a:p>
@@ -3590,27 +3747,27 @@
               </a:spcAft>
             </a:pPr>
             <a:r>
-              <a:rPr sz="900" b="0">
-                <a:solidFill>
-                  <a:srgbClr val="888899"/>
-                </a:solidFill>
-                <a:latin typeface="Consolas"/>
-              </a:rPr>
-              <a:t>Step toward it</a:t>
-            </a:r>
-          </a:p>
-        </p:txBody>
-      </p:sp>
-      <p:sp>
-        <p:nvSpPr>
-          <p:cNvPr id="11" name="TextBox 10"/>
+              <a:rPr sz="1000" b="0">
+                <a:solidFill>
+                  <a:srgbClr val="FFFFFF"/>
+                </a:solidFill>
+                <a:latin typeface="Consolas"/>
+              </a:rPr>
+              <a:t>one step toward it</a:t>
+            </a:r>
+          </a:p>
+        </p:txBody>
+      </p:sp>
+      <p:sp>
+        <p:nvSpPr>
+          <p:cNvPr id="14" name="TextBox 13"/>
           <p:cNvSpPr txBox="1"/>
           <p:nvPr/>
         </p:nvSpPr>
         <p:spPr>
           <a:xfrm>
-            <a:off x="3200400" y="3063240"/>
-            <a:ext cx="548640" cy="274320"/>
+            <a:off x="3200400" y="2926080"/>
+            <a:ext cx="640080" cy="274320"/>
           </a:xfrm>
           <a:prstGeom prst="rect">
             <a:avLst/>
@@ -3625,7 +3782,7 @@
           <a:p>
             <a:pPr algn="ctr"/>
             <a:r>
-              <a:rPr sz="1000" b="1">
+              <a:rPr sz="1100" b="1">
                 <a:solidFill>
                   <a:srgbClr val="4FDF6F"/>
                 </a:solidFill>
@@ -3638,14 +3795,14 @@
       </p:sp>
       <p:cxnSp>
         <p:nvCxnSpPr>
-          <p:cNvPr id="12" name="Connector 11"/>
+          <p:cNvPr id="15" name="Connector 14"/>
           <p:cNvCxnSpPr/>
           <p:nvPr/>
         </p:nvCxnSpPr>
         <p:spPr>
           <a:xfrm>
-            <a:off x="5303520" y="3840480"/>
-            <a:ext cx="0" cy="274320"/>
+            <a:off x="5303520" y="3703320"/>
+            <a:ext cx="0" cy="228600"/>
           </a:xfrm>
           <a:prstGeom prst="line">
             <a:avLst/>
@@ -3673,13 +3830,13 @@
       </p:cxnSp>
       <p:sp>
         <p:nvSpPr>
-          <p:cNvPr id="13" name="TextBox 12"/>
+          <p:cNvPr id="16" name="TextBox 15"/>
           <p:cNvSpPr txBox="1"/>
           <p:nvPr/>
         </p:nvSpPr>
         <p:spPr>
           <a:xfrm>
-            <a:off x="5394960" y="3794760"/>
+            <a:off x="5394960" y="3657600"/>
             <a:ext cx="457200" cy="274320"/>
           </a:xfrm>
           <a:prstGeom prst="rect">
@@ -3695,7 +3852,7 @@
           <a:p>
             <a:pPr algn="l"/>
             <a:r>
-              <a:rPr sz="1000" b="1">
+              <a:rPr sz="1100" b="1">
                 <a:solidFill>
                   <a:srgbClr val="E06060"/>
                 </a:solidFill>
@@ -3708,13 +3865,48 @@
       </p:sp>
       <p:sp>
         <p:nvSpPr>
-          <p:cNvPr id="14" name="Diamond 13"/>
+          <p:cNvPr id="17" name="TextBox 16"/>
+          <p:cNvSpPr txBox="1"/>
+          <p:nvPr/>
+        </p:nvSpPr>
+        <p:spPr>
+          <a:xfrm>
+            <a:off x="137160" y="4069080"/>
+            <a:ext cx="822960" cy="320040"/>
+          </a:xfrm>
+          <a:prstGeom prst="rect">
+            <a:avLst/>
+          </a:prstGeom>
+          <a:noFill/>
+        </p:spPr>
+        <p:txBody>
+          <a:bodyPr wrap="square">
+            <a:spAutoFit/>
+          </a:bodyPr>
+          <a:lstStyle/>
+          <a:p>
+            <a:pPr algn="ctr"/>
+            <a:r>
+              <a:rPr sz="900" b="1">
+                <a:solidFill>
+                  <a:srgbClr val="FFD700"/>
+                </a:solidFill>
+                <a:latin typeface="Consolas"/>
+              </a:rPr>
+              <a:t>STEP 4</a:t>
+            </a:r>
+          </a:p>
+        </p:txBody>
+      </p:sp>
+      <p:sp>
+        <p:nvSpPr>
+          <p:cNvPr id="18" name="Diamond 17"/>
           <p:cNvSpPr/>
           <p:nvPr/>
         </p:nvSpPr>
         <p:spPr>
           <a:xfrm>
-            <a:off x="4023360" y="4114800"/>
+            <a:off x="4023360" y="3931920"/>
             <a:ext cx="2560320" cy="914400"/>
           </a:xfrm>
           <a:prstGeom prst="diamond">
@@ -3754,13 +3946,13 @@
               </a:spcAft>
             </a:pPr>
             <a:r>
-              <a:rPr sz="1100" b="1">
+              <a:rPr sz="1200" b="1">
                 <a:solidFill>
                   <a:srgbClr val="2ACFAF"/>
                 </a:solidFill>
                 <a:latin typeface="Consolas"/>
               </a:rPr>
-              <a:t>roll &lt; +15%?</a:t>
+              <a:t>Is the player nearby?</a:t>
             </a:r>
           </a:p>
           <a:p>
@@ -3772,25 +3964,41 @@
             <a:r>
               <a:rPr sz="900" b="0">
                 <a:solidFill>
-                  <a:srgbClr val="888899"/>
-                </a:solidFill>
-                <a:latin typeface="Consolas"/>
-              </a:rPr>
-              <a:t>player &lt; 10 tiles</a:t>
+                  <a:srgbClr val="AAAABB"/>
+                </a:solidFill>
+                <a:latin typeface="Consolas"/>
+              </a:rPr>
+              <a:t>extra 15% chance &amp;</a:t>
+            </a:r>
+          </a:p>
+          <a:p>
+            <a:pPr algn="ctr">
+              <a:spcAft>
+                <a:spcPts val="200"/>
+              </a:spcAft>
+            </a:pPr>
+            <a:r>
+              <a:rPr sz="900" b="0">
+                <a:solidFill>
+                  <a:srgbClr val="AAAABB"/>
+                </a:solidFill>
+                <a:latin typeface="Consolas"/>
+              </a:rPr>
+              <a:t>ARKE within 10 tiles</a:t>
             </a:r>
           </a:p>
         </p:txBody>
       </p:sp>
       <p:cxnSp>
         <p:nvCxnSpPr>
-          <p:cNvPr id="15" name="Connector 14"/>
+          <p:cNvPr id="19" name="Connector 18"/>
           <p:cNvCxnSpPr/>
           <p:nvPr/>
         </p:nvCxnSpPr>
         <p:spPr>
           <a:xfrm>
-            <a:off x="6583680" y="4572000"/>
-            <a:ext cx="2560320" cy="0"/>
+            <a:off x="6583680" y="4389120"/>
+            <a:ext cx="2377440" cy="0"/>
           </a:xfrm>
           <a:prstGeom prst="line">
             <a:avLst/>
@@ -3818,14 +4026,14 @@
       </p:cxnSp>
       <p:sp>
         <p:nvSpPr>
-          <p:cNvPr id="16" name="Rounded Rectangle 15"/>
+          <p:cNvPr id="20" name="Rounded Rectangle 19"/>
           <p:cNvSpPr/>
           <p:nvPr/>
         </p:nvSpPr>
         <p:spPr>
           <a:xfrm>
-            <a:off x="9144000" y="4069080"/>
-            <a:ext cx="2377440" cy="1005840"/>
+            <a:off x="8961120" y="3794760"/>
+            <a:ext cx="2560320" cy="1188720"/>
           </a:xfrm>
           <a:prstGeom prst="roundRect">
             <a:avLst/>
@@ -3864,7 +4072,7 @@
               </a:spcAft>
             </a:pPr>
             <a:r>
-              <a:rPr sz="1400" b="1">
+              <a:rPr sz="1500" b="1">
                 <a:solidFill>
                   <a:srgbClr val="2ACFAF"/>
                 </a:solidFill>
@@ -3880,13 +4088,29 @@
               </a:spcAft>
             </a:pPr>
             <a:r>
+              <a:rPr sz="400" b="0">
+                <a:solidFill>
+                  <a:srgbClr val="2ACFAF"/>
+                </a:solidFill>
+                <a:latin typeface="Consolas"/>
+              </a:rPr>
+              <a:t/>
+            </a:r>
+          </a:p>
+          <a:p>
+            <a:pPr algn="ctr">
+              <a:spcAft>
+                <a:spcPts val="200"/>
+              </a:spcAft>
+            </a:pPr>
+            <a:r>
               <a:rPr sz="1000" b="0">
                 <a:solidFill>
-                  <a:srgbClr val="50B0C0"/>
-                </a:solidFill>
-                <a:latin typeface="Consolas"/>
-              </a:rPr>
-              <a:t>_step_toward()</a:t>
+                  <a:srgbClr val="FFFFFF"/>
+                </a:solidFill>
+                <a:latin typeface="Consolas"/>
+              </a:rPr>
+              <a:t>The player (ARKE) is close!</a:t>
             </a:r>
           </a:p>
           <a:p>
@@ -3896,13 +4120,13 @@
               </a:spcAft>
             </a:pPr>
             <a:r>
-              <a:rPr sz="900" b="0">
-                <a:solidFill>
-                  <a:srgbClr val="888899"/>
-                </a:solidFill>
-                <a:latin typeface="Consolas"/>
-              </a:rPr>
-              <a:t>Move toward player</a:t>
+              <a:rPr sz="1000" b="0">
+                <a:solidFill>
+                  <a:srgbClr val="FFFFFF"/>
+                </a:solidFill>
+                <a:latin typeface="Consolas"/>
+              </a:rPr>
+              <a:t>Chase them to compete</a:t>
             </a:r>
           </a:p>
           <a:p>
@@ -3912,13 +4136,13 @@
               </a:spcAft>
             </a:pPr>
             <a:r>
-              <a:rPr sz="900" b="0">
-                <a:solidFill>
-                  <a:srgbClr val="888899"/>
-                </a:solidFill>
-                <a:latin typeface="Consolas"/>
-              </a:rPr>
-              <a:t>PLAYER_SENSE = 10</a:t>
+              <a:rPr sz="1000" b="0">
+                <a:solidFill>
+                  <a:srgbClr val="FFFFFF"/>
+                </a:solidFill>
+                <a:latin typeface="Consolas"/>
+              </a:rPr>
+              <a:t>for the same food zone.</a:t>
             </a:r>
           </a:p>
           <a:p>
@@ -3928,27 +4152,27 @@
               </a:spcAft>
             </a:pPr>
             <a:r>
-              <a:rPr sz="900" b="0">
-                <a:solidFill>
-                  <a:srgbClr val="888899"/>
-                </a:solidFill>
-                <a:latin typeface="Consolas"/>
-              </a:rPr>
-              <a:t>Compete for food zone</a:t>
-            </a:r>
-          </a:p>
-        </p:txBody>
-      </p:sp>
-      <p:sp>
-        <p:nvSpPr>
-          <p:cNvPr id="17" name="TextBox 16"/>
+              <a:rPr sz="1000" b="0">
+                <a:solidFill>
+                  <a:srgbClr val="FFFFFF"/>
+                </a:solidFill>
+                <a:latin typeface="Consolas"/>
+              </a:rPr>
+              <a:t>Move one step toward ARKE.</a:t>
+            </a:r>
+          </a:p>
+        </p:txBody>
+      </p:sp>
+      <p:sp>
+        <p:nvSpPr>
+          <p:cNvPr id="21" name="TextBox 20"/>
           <p:cNvSpPr txBox="1"/>
           <p:nvPr/>
         </p:nvSpPr>
         <p:spPr>
           <a:xfrm>
-            <a:off x="6675120" y="4251960"/>
-            <a:ext cx="548640" cy="274320"/>
+            <a:off x="6675120" y="4069080"/>
+            <a:ext cx="640080" cy="274320"/>
           </a:xfrm>
           <a:prstGeom prst="rect">
             <a:avLst/>
@@ -3963,7 +4187,7 @@
           <a:p>
             <a:pPr algn="ctr"/>
             <a:r>
-              <a:rPr sz="1000" b="1">
+              <a:rPr sz="1100" b="1">
                 <a:solidFill>
                   <a:srgbClr val="2ACFAF"/>
                 </a:solidFill>
@@ -3976,13 +4200,13 @@
       </p:sp>
       <p:cxnSp>
         <p:nvCxnSpPr>
-          <p:cNvPr id="18" name="Connector 17"/>
+          <p:cNvPr id="22" name="Connector 21"/>
           <p:cNvCxnSpPr/>
           <p:nvPr/>
         </p:nvCxnSpPr>
         <p:spPr>
           <a:xfrm>
-            <a:off x="5303520" y="5029200"/>
+            <a:off x="5303520" y="4846320"/>
             <a:ext cx="0" cy="182880"/>
           </a:xfrm>
           <a:prstGeom prst="line">
@@ -4011,13 +4235,13 @@
       </p:cxnSp>
       <p:sp>
         <p:nvSpPr>
-          <p:cNvPr id="19" name="TextBox 18"/>
+          <p:cNvPr id="23" name="TextBox 22"/>
           <p:cNvSpPr txBox="1"/>
           <p:nvPr/>
         </p:nvSpPr>
         <p:spPr>
           <a:xfrm>
-            <a:off x="5394960" y="4983480"/>
+            <a:off x="5394960" y="4800600"/>
             <a:ext cx="457200" cy="274320"/>
           </a:xfrm>
           <a:prstGeom prst="rect">
@@ -4033,7 +4257,7 @@
           <a:p>
             <a:pPr algn="l"/>
             <a:r>
-              <a:rPr sz="1000" b="1">
+              <a:rPr sz="1100" b="1">
                 <a:solidFill>
                   <a:srgbClr val="E06060"/>
                 </a:solidFill>
@@ -4046,13 +4270,48 @@
       </p:sp>
       <p:sp>
         <p:nvSpPr>
-          <p:cNvPr id="20" name="Diamond 19"/>
+          <p:cNvPr id="24" name="TextBox 23"/>
+          <p:cNvSpPr txBox="1"/>
+          <p:nvPr/>
+        </p:nvSpPr>
+        <p:spPr>
+          <a:xfrm>
+            <a:off x="137160" y="5166360"/>
+            <a:ext cx="822960" cy="320040"/>
+          </a:xfrm>
+          <a:prstGeom prst="rect">
+            <a:avLst/>
+          </a:prstGeom>
+          <a:noFill/>
+        </p:spPr>
+        <p:txBody>
+          <a:bodyPr wrap="square">
+            <a:spAutoFit/>
+          </a:bodyPr>
+          <a:lstStyle/>
+          <a:p>
+            <a:pPr algn="ctr"/>
+            <a:r>
+              <a:rPr sz="900" b="1">
+                <a:solidFill>
+                  <a:srgbClr val="FFD700"/>
+                </a:solidFill>
+                <a:latin typeface="Consolas"/>
+              </a:rPr>
+              <a:t>STEP 5</a:t>
+            </a:r>
+          </a:p>
+        </p:txBody>
+      </p:sp>
+      <p:sp>
+        <p:nvSpPr>
+          <p:cNvPr id="25" name="Diamond 24"/>
           <p:cNvSpPr/>
           <p:nvPr/>
         </p:nvSpPr>
         <p:spPr>
           <a:xfrm>
-            <a:off x="4023360" y="5212080"/>
+            <a:off x="4023360" y="5029200"/>
             <a:ext cx="2560320" cy="914400"/>
           </a:xfrm>
           <a:prstGeom prst="diamond">
@@ -4092,13 +4351,13 @@
               </a:spcAft>
             </a:pPr>
             <a:r>
-              <a:rPr sz="1100" b="1">
+              <a:rPr sz="1200" b="1">
                 <a:solidFill>
                   <a:srgbClr val="4FA4FF"/>
                 </a:solidFill>
                 <a:latin typeface="Consolas"/>
               </a:rPr>
-              <a:t>flow &gt; 0.1 &amp;</a:t>
+              <a:t>Is there water flow?</a:t>
             </a:r>
           </a:p>
           <a:p>
@@ -4108,26 +4367,42 @@
               </a:spcAft>
             </a:pPr>
             <a:r>
-              <a:rPr sz="1100" b="1">
-                <a:solidFill>
-                  <a:srgbClr val="4FA4FF"/>
-                </a:solidFill>
-                <a:latin typeface="Consolas"/>
-              </a:rPr>
-              <a:t>40% chance?</a:t>
+              <a:rPr sz="900" b="0">
+                <a:solidFill>
+                  <a:srgbClr val="AAAABB"/>
+                </a:solidFill>
+                <a:latin typeface="Consolas"/>
+              </a:rPr>
+              <a:t>flow speed &gt; 0.1 &amp;</a:t>
+            </a:r>
+          </a:p>
+          <a:p>
+            <a:pPr algn="ctr">
+              <a:spcAft>
+                <a:spcPts val="200"/>
+              </a:spcAft>
+            </a:pPr>
+            <a:r>
+              <a:rPr sz="900" b="0">
+                <a:solidFill>
+                  <a:srgbClr val="AAAABB"/>
+                </a:solidFill>
+                <a:latin typeface="Consolas"/>
+              </a:rPr>
+              <a:t>40% random chance</a:t>
             </a:r>
           </a:p>
         </p:txBody>
       </p:sp>
       <p:cxnSp>
         <p:nvCxnSpPr>
-          <p:cNvPr id="21" name="Connector 20"/>
+          <p:cNvPr id="26" name="Connector 25"/>
           <p:cNvCxnSpPr/>
           <p:nvPr/>
         </p:nvCxnSpPr>
         <p:spPr>
           <a:xfrm flipH="1">
-            <a:off x="3474720" y="5669280"/>
+            <a:off x="3474720" y="5486400"/>
             <a:ext cx="548640" cy="0"/>
           </a:xfrm>
           <a:prstGeom prst="line">
@@ -4156,14 +4431,14 @@
       </p:cxnSp>
       <p:sp>
         <p:nvSpPr>
-          <p:cNvPr id="22" name="Rounded Rectangle 21"/>
+          <p:cNvPr id="27" name="Rounded Rectangle 26"/>
           <p:cNvSpPr/>
           <p:nvPr/>
         </p:nvSpPr>
         <p:spPr>
           <a:xfrm>
-            <a:off x="1097280" y="5166360"/>
-            <a:ext cx="2377440" cy="1005840"/>
+            <a:off x="914400" y="4892040"/>
+            <a:ext cx="2560320" cy="1188720"/>
           </a:xfrm>
           <a:prstGeom prst="roundRect">
             <a:avLst/>
@@ -4202,13 +4477,13 @@
               </a:spcAft>
             </a:pPr>
             <a:r>
-              <a:rPr sz="1400" b="1">
+              <a:rPr sz="1500" b="1">
                 <a:solidFill>
                   <a:srgbClr val="4FA4FF"/>
                 </a:solidFill>
                 <a:latin typeface="Consolas"/>
               </a:rPr>
-              <a:t>RIDE FLOW</a:t>
+              <a:t>RIDE THE FLOW</a:t>
             </a:r>
           </a:p>
           <a:p>
@@ -4218,13 +4493,29 @@
               </a:spcAft>
             </a:pPr>
             <a:r>
+              <a:rPr sz="400" b="0">
+                <a:solidFill>
+                  <a:srgbClr val="4FA4FF"/>
+                </a:solidFill>
+                <a:latin typeface="Consolas"/>
+              </a:rPr>
+              <a:t/>
+            </a:r>
+          </a:p>
+          <a:p>
+            <a:pPr algn="ctr">
+              <a:spcAft>
+                <a:spcPts val="200"/>
+              </a:spcAft>
+            </a:pPr>
+            <a:r>
               <a:rPr sz="1000" b="0">
                 <a:solidFill>
-                  <a:srgbClr val="50B0C0"/>
-                </a:solidFill>
-                <a:latin typeface="Consolas"/>
-              </a:rPr>
-              <a:t>get_flow(tile_x, tile_y)</a:t>
+                  <a:srgbClr val="FFFFFF"/>
+                </a:solidFill>
+                <a:latin typeface="Consolas"/>
+              </a:rPr>
+              <a:t>There is a water current</a:t>
             </a:r>
           </a:p>
           <a:p>
@@ -4234,13 +4525,13 @@
               </a:spcAft>
             </a:pPr>
             <a:r>
-              <a:rPr sz="900" b="0">
-                <a:solidFill>
-                  <a:srgbClr val="888899"/>
-                </a:solidFill>
-                <a:latin typeface="Consolas"/>
-              </a:rPr>
-              <a:t>Follow flow_dir</a:t>
+              <a:rPr sz="1000" b="0">
+                <a:solidFill>
+                  <a:srgbClr val="FFFFFF"/>
+                </a:solidFill>
+                <a:latin typeface="Consolas"/>
+              </a:rPr>
+              <a:t>at this tile. Drift along</a:t>
             </a:r>
           </a:p>
           <a:p>
@@ -4250,13 +4541,13 @@
               </a:spcAft>
             </a:pPr>
             <a:r>
-              <a:rPr sz="900" b="0">
-                <a:solidFill>
-                  <a:srgbClr val="888899"/>
-                </a:solidFill>
-                <a:latin typeface="Consolas"/>
-              </a:rPr>
-              <a:t>speed &gt; 0.1 required</a:t>
+              <a:rPr sz="1000" b="0">
+                <a:solidFill>
+                  <a:srgbClr val="FFFFFF"/>
+                </a:solidFill>
+                <a:latin typeface="Consolas"/>
+              </a:rPr>
+              <a:t>with it (like a river).</a:t>
             </a:r>
           </a:p>
           <a:p>
@@ -4266,27 +4557,27 @@
               </a:spcAft>
             </a:pPr>
             <a:r>
-              <a:rPr sz="900" b="0">
-                <a:solidFill>
-                  <a:srgbClr val="888899"/>
-                </a:solidFill>
-                <a:latin typeface="Consolas"/>
-              </a:rPr>
-              <a:t>40% chance per tick</a:t>
-            </a:r>
-          </a:p>
-        </p:txBody>
-      </p:sp>
-      <p:sp>
-        <p:nvSpPr>
-          <p:cNvPr id="23" name="TextBox 22"/>
+              <a:rPr sz="1000" b="0">
+                <a:solidFill>
+                  <a:srgbClr val="FFFFFF"/>
+                </a:solidFill>
+                <a:latin typeface="Consolas"/>
+              </a:rPr>
+              <a:t>Only if flow speed &gt; 0.1</a:t>
+            </a:r>
+          </a:p>
+        </p:txBody>
+      </p:sp>
+      <p:sp>
+        <p:nvSpPr>
+          <p:cNvPr id="28" name="TextBox 27"/>
           <p:cNvSpPr txBox="1"/>
           <p:nvPr/>
         </p:nvSpPr>
         <p:spPr>
           <a:xfrm>
-            <a:off x="3200400" y="5349240"/>
-            <a:ext cx="548640" cy="274320"/>
+            <a:off x="3200400" y="5166360"/>
+            <a:ext cx="640080" cy="274320"/>
           </a:xfrm>
           <a:prstGeom prst="rect">
             <a:avLst/>
@@ -4301,7 +4592,7 @@
           <a:p>
             <a:pPr algn="ctr"/>
             <a:r>
-              <a:rPr sz="1000" b="1">
+              <a:rPr sz="1100" b="1">
                 <a:solidFill>
                   <a:srgbClr val="4FA4FF"/>
                 </a:solidFill>
@@ -4314,14 +4605,14 @@
       </p:sp>
       <p:cxnSp>
         <p:nvCxnSpPr>
-          <p:cNvPr id="24" name="Connector 23"/>
+          <p:cNvPr id="29" name="Connector 28"/>
           <p:cNvCxnSpPr/>
           <p:nvPr/>
         </p:nvCxnSpPr>
         <p:spPr>
           <a:xfrm flipV="1">
-            <a:off x="5303520" y="5943600"/>
-            <a:ext cx="0" cy="182880"/>
+            <a:off x="5303520" y="5897880"/>
+            <a:ext cx="0" cy="45720"/>
           </a:xfrm>
           <a:prstGeom prst="line">
             <a:avLst/>
@@ -4349,13 +4640,13 @@
       </p:cxnSp>
       <p:sp>
         <p:nvSpPr>
-          <p:cNvPr id="25" name="TextBox 24"/>
+          <p:cNvPr id="30" name="TextBox 29"/>
           <p:cNvSpPr txBox="1"/>
           <p:nvPr/>
         </p:nvSpPr>
         <p:spPr>
           <a:xfrm>
-            <a:off x="5394960" y="6080760"/>
+            <a:off x="5394960" y="5897880"/>
             <a:ext cx="457200" cy="274320"/>
           </a:xfrm>
           <a:prstGeom prst="rect">
@@ -4371,7 +4662,7 @@
           <a:p>
             <a:pPr algn="l"/>
             <a:r>
-              <a:rPr sz="1000" b="1">
+              <a:rPr sz="1100" b="1">
                 <a:solidFill>
                   <a:srgbClr val="E06060"/>
                 </a:solidFill>
@@ -4384,14 +4675,49 @@
       </p:sp>
       <p:sp>
         <p:nvSpPr>
-          <p:cNvPr id="26" name="Rounded Rectangle 25"/>
+          <p:cNvPr id="31" name="TextBox 30"/>
+          <p:cNvSpPr txBox="1"/>
+          <p:nvPr/>
+        </p:nvSpPr>
+        <p:spPr>
+          <a:xfrm>
+            <a:off x="137160" y="5943600"/>
+            <a:ext cx="822960" cy="320040"/>
+          </a:xfrm>
+          <a:prstGeom prst="rect">
+            <a:avLst/>
+          </a:prstGeom>
+          <a:noFill/>
+        </p:spPr>
+        <p:txBody>
+          <a:bodyPr wrap="square">
+            <a:spAutoFit/>
+          </a:bodyPr>
+          <a:lstStyle/>
+          <a:p>
+            <a:pPr algn="ctr"/>
+            <a:r>
+              <a:rPr sz="900" b="1">
+                <a:solidFill>
+                  <a:srgbClr val="FFD700"/>
+                </a:solidFill>
+                <a:latin typeface="Consolas"/>
+              </a:rPr>
+              <a:t>STEP 6</a:t>
+            </a:r>
+          </a:p>
+        </p:txBody>
+      </p:sp>
+      <p:sp>
+        <p:nvSpPr>
+          <p:cNvPr id="32" name="Rounded Rectangle 31"/>
           <p:cNvSpPr/>
           <p:nvPr/>
         </p:nvSpPr>
         <p:spPr>
           <a:xfrm>
-            <a:off x="4114800" y="5943600"/>
-            <a:ext cx="2377440" cy="594360"/>
+            <a:off x="3931920" y="5897880"/>
+            <a:ext cx="2743200" cy="640080"/>
           </a:xfrm>
           <a:prstGeom prst="roundRect">
             <a:avLst/>
@@ -4436,7 +4762,7 @@
                 </a:solidFill>
                 <a:latin typeface="Consolas"/>
               </a:rPr>
-              <a:t>WANDER</a:t>
+              <a:t>WANDER RANDOMLY</a:t>
             </a:r>
           </a:p>
           <a:p>
@@ -4448,25 +4774,25 @@
             <a:r>
               <a:rPr sz="900" b="0">
                 <a:solidFill>
-                  <a:srgbClr val="888899"/>
-                </a:solidFill>
-                <a:latin typeface="Consolas"/>
-              </a:rPr>
-              <a:t>Try preferred dir → shuffle random</a:t>
-            </a:r>
-          </a:p>
-        </p:txBody>
-      </p:sp>
-      <p:sp>
-        <p:nvSpPr>
-          <p:cNvPr id="27" name="Rounded Rectangle 26"/>
+                  <a:srgbClr val="AAAABB"/>
+                </a:solidFill>
+                <a:latin typeface="Consolas"/>
+              </a:rPr>
+              <a:t>Nothing else worked — pick a random direction</a:t>
+            </a:r>
+          </a:p>
+        </p:txBody>
+      </p:sp>
+      <p:sp>
+        <p:nvSpPr>
+          <p:cNvPr id="33" name="Rounded Rectangle 32"/>
           <p:cNvSpPr/>
           <p:nvPr/>
         </p:nvSpPr>
         <p:spPr>
           <a:xfrm>
-            <a:off x="9144000" y="2468880"/>
-            <a:ext cx="2560320" cy="1371600"/>
+            <a:off x="9144000" y="2240280"/>
+            <a:ext cx="2743200" cy="1828800"/>
           </a:xfrm>
           <a:prstGeom prst="roundRect">
             <a:avLst/>
@@ -4505,7 +4831,7 @@
               </a:spcAft>
             </a:pPr>
             <a:r>
-              <a:rPr sz="1300" b="1">
+              <a:rPr sz="1400" b="1">
                 <a:solidFill>
                   <a:srgbClr val="E06060"/>
                 </a:solidFill>
@@ -4521,7 +4847,7 @@
               </a:spcAft>
             </a:pPr>
             <a:r>
-              <a:rPr sz="600" b="0">
+              <a:rPr sz="400" b="0">
                 <a:solidFill>
                   <a:srgbClr val="888899"/>
                 </a:solidFill>
@@ -4539,6 +4865,22 @@
             <a:r>
               <a:rPr sz="1000" b="0">
                 <a:solidFill>
+                  <a:srgbClr val="FFFFFF"/>
+                </a:solidFill>
+                <a:latin typeface="Consolas"/>
+              </a:rPr>
+              <a:t>Every frame, hunger grows:</a:t>
+            </a:r>
+          </a:p>
+          <a:p>
+            <a:pPr algn="ctr">
+              <a:spcAft>
+                <a:spcPts val="200"/>
+              </a:spcAft>
+            </a:pPr>
+            <a:r>
+              <a:rPr sz="1000" b="0">
+                <a:solidFill>
                   <a:srgbClr val="50B0C0"/>
                 </a:solidFill>
                 <a:latin typeface="Consolas"/>
@@ -4553,7 +4895,7 @@
               </a:spcAft>
             </a:pPr>
             <a:r>
-              <a:rPr sz="600" b="0">
+              <a:rPr sz="400" b="0">
                 <a:solidFill>
                   <a:srgbClr val="888899"/>
                 </a:solidFill>
@@ -4575,7 +4917,7 @@
                 </a:solidFill>
                 <a:latin typeface="Consolas"/>
               </a:rPr>
-              <a:t>seek_chance =</a:t>
+              <a:t>The hungrier the rival,</a:t>
             </a:r>
           </a:p>
           <a:p>
@@ -4587,11 +4929,11 @@
             <a:r>
               <a:rPr sz="1000" b="0">
                 <a:solidFill>
-                  <a:srgbClr val="FFFF5F"/>
-                </a:solidFill>
-                <a:latin typeface="Consolas"/>
-              </a:rPr>
-              <a:t>  0.45 + hunger * 0.05</a:t>
+                  <a:srgbClr val="FFFFFF"/>
+                </a:solidFill>
+                <a:latin typeface="Consolas"/>
+              </a:rPr>
+              <a:t>the MORE LIKELY it will</a:t>
             </a:r>
           </a:p>
           <a:p>
@@ -4601,13 +4943,184 @@
               </a:spcAft>
             </a:pPr>
             <a:r>
+              <a:rPr sz="1000" b="0">
+                <a:solidFill>
+                  <a:srgbClr val="FFFFFF"/>
+                </a:solidFill>
+                <a:latin typeface="Consolas"/>
+              </a:rPr>
+              <a:t>choose "Seek Food".</a:t>
+            </a:r>
+          </a:p>
+          <a:p>
+            <a:pPr algn="ctr">
+              <a:spcAft>
+                <a:spcPts val="200"/>
+              </a:spcAft>
+            </a:pPr>
+            <a:r>
+              <a:rPr sz="400" b="0">
+                <a:solidFill>
+                  <a:srgbClr val="888899"/>
+                </a:solidFill>
+                <a:latin typeface="Consolas"/>
+              </a:rPr>
+              <a:t/>
+            </a:r>
+          </a:p>
+          <a:p>
+            <a:pPr algn="ctr">
+              <a:spcAft>
+                <a:spcPts val="200"/>
+              </a:spcAft>
+            </a:pPr>
+            <a:r>
+              <a:rPr sz="1000" b="0">
+                <a:solidFill>
+                  <a:srgbClr val="AAAABB"/>
+                </a:solidFill>
+                <a:latin typeface="Consolas"/>
+              </a:rPr>
+              <a:t>seek_chance:</a:t>
+            </a:r>
+          </a:p>
+          <a:p>
+            <a:pPr algn="ctr">
+              <a:spcAft>
+                <a:spcPts val="200"/>
+              </a:spcAft>
+            </a:pPr>
+            <a:r>
+              <a:rPr sz="1000" b="0">
+                <a:solidFill>
+                  <a:srgbClr val="4FDF6F"/>
+                </a:solidFill>
+                <a:latin typeface="Consolas"/>
+              </a:rPr>
+              <a:t>  low hunger  = 45%</a:t>
+            </a:r>
+          </a:p>
+          <a:p>
+            <a:pPr algn="ctr">
+              <a:spcAft>
+                <a:spcPts val="200"/>
+              </a:spcAft>
+            </a:pPr>
+            <a:r>
+              <a:rPr sz="1000" b="0">
+                <a:solidFill>
+                  <a:srgbClr val="E06060"/>
+                </a:solidFill>
+                <a:latin typeface="Consolas"/>
+              </a:rPr>
+              <a:t>  high hunger = 75%</a:t>
+            </a:r>
+          </a:p>
+          <a:p>
+            <a:pPr algn="ctr">
+              <a:spcAft>
+                <a:spcPts val="200"/>
+              </a:spcAft>
+            </a:pPr>
+            <a:r>
+              <a:rPr sz="400" b="0">
+                <a:solidFill>
+                  <a:srgbClr val="888899"/>
+                </a:solidFill>
+                <a:latin typeface="Consolas"/>
+              </a:rPr>
+              <a:t/>
+            </a:r>
+          </a:p>
+          <a:p>
+            <a:pPr algn="ctr">
+              <a:spcAft>
+                <a:spcPts val="200"/>
+              </a:spcAft>
+            </a:pPr>
+            <a:r>
               <a:rPr sz="900" b="0">
                 <a:solidFill>
+                  <a:srgbClr val="4FDF6F"/>
+                </a:solidFill>
+                <a:latin typeface="Consolas"/>
+              </a:rPr>
+              <a:t>Eating resets hunger to 0</a:t>
+            </a:r>
+          </a:p>
+        </p:txBody>
+      </p:sp>
+      <p:sp>
+        <p:nvSpPr>
+          <p:cNvPr id="34" name="Rounded Rectangle 33"/>
+          <p:cNvSpPr/>
+          <p:nvPr/>
+        </p:nvSpPr>
+        <p:spPr>
+          <a:xfrm>
+            <a:off x="9144000" y="4023360"/>
+            <a:ext cx="2743200" cy="1920240"/>
+          </a:xfrm>
+          <a:prstGeom prst="roundRect">
+            <a:avLst/>
+          </a:prstGeom>
+          <a:solidFill>
+            <a:srgbClr val="101020"/>
+          </a:solidFill>
+          <a:ln w="25400">
+            <a:solidFill>
+              <a:srgbClr val="CF6FFF"/>
+            </a:solidFill>
+          </a:ln>
+          <a:effectLst/>
+        </p:spPr>
+        <p:style>
+          <a:lnRef idx="1">
+            <a:schemeClr val="accent1"/>
+          </a:lnRef>
+          <a:fillRef idx="3">
+            <a:schemeClr val="accent1"/>
+          </a:fillRef>
+          <a:effectRef idx="2">
+            <a:schemeClr val="accent1"/>
+          </a:effectRef>
+          <a:fontRef idx="minor">
+            <a:schemeClr val="lt1"/>
+          </a:fontRef>
+        </p:style>
+        <p:txBody>
+          <a:bodyPr rtlCol="0" anchor="ctr" wrap="square"/>
+          <a:lstStyle/>
+          <a:p>
+            <a:pPr algn="ctr">
+              <a:spcAft>
+                <a:spcPts val="200"/>
+              </a:spcAft>
+            </a:pPr>
+            <a:r>
+              <a:rPr sz="1400" b="1">
+                <a:solidFill>
+                  <a:srgbClr val="CF6FFF"/>
+                </a:solidFill>
+                <a:latin typeface="Consolas"/>
+              </a:rPr>
+              <a:t>WHAT IS "delta"?</a:t>
+            </a:r>
+          </a:p>
+          <a:p>
+            <a:pPr algn="ctr">
+              <a:spcAft>
+                <a:spcPts val="200"/>
+              </a:spcAft>
+            </a:pPr>
+            <a:r>
+              <a:rPr sz="400" b="0">
+                <a:solidFill>
                   <a:srgbClr val="888899"/>
                 </a:solidFill>
                 <a:latin typeface="Consolas"/>
               </a:rPr>
-              <a:t>  clamped to [0.45, 0.75]</a:t>
+              <a:t/>
             </a:r>
           </a:p>
           <a:p>
@@ -4617,7 +5130,39 @@
               </a:spcAft>
             </a:pPr>
             <a:r>
-              <a:rPr sz="600" b="0">
+              <a:rPr sz="1000" b="0">
+                <a:solidFill>
+                  <a:srgbClr val="FFFFFF"/>
+                </a:solidFill>
+                <a:latin typeface="Consolas"/>
+              </a:rPr>
+              <a:t>delta = the time (in seconds)</a:t>
+            </a:r>
+          </a:p>
+          <a:p>
+            <a:pPr algn="ctr">
+              <a:spcAft>
+                <a:spcPts val="200"/>
+              </a:spcAft>
+            </a:pPr>
+            <a:r>
+              <a:rPr sz="1000" b="0">
+                <a:solidFill>
+                  <a:srgbClr val="FFFFFF"/>
+                </a:solidFill>
+                <a:latin typeface="Consolas"/>
+              </a:rPr>
+              <a:t>since the last frame was drawn.</a:t>
+            </a:r>
+          </a:p>
+          <a:p>
+            <a:pPr algn="ctr">
+              <a:spcAft>
+                <a:spcPts val="200"/>
+              </a:spcAft>
+            </a:pPr>
+            <a:r>
+              <a:rPr sz="400" b="0">
                 <a:solidFill>
                   <a:srgbClr val="888899"/>
                 </a:solidFill>
@@ -4633,26 +5178,218 @@
               </a:spcAft>
             </a:pPr>
             <a:r>
+              <a:rPr sz="1000" b="0">
+                <a:solidFill>
+                  <a:srgbClr val="AAAABB"/>
+                </a:solidFill>
+                <a:latin typeface="Consolas"/>
+              </a:rPr>
+              <a:t>At 60 FPS:</a:t>
+            </a:r>
+          </a:p>
+          <a:p>
+            <a:pPr algn="ctr">
+              <a:spcAft>
+                <a:spcPts val="200"/>
+              </a:spcAft>
+            </a:pPr>
+            <a:r>
+              <a:rPr sz="1000" b="0">
+                <a:solidFill>
+                  <a:srgbClr val="50B0C0"/>
+                </a:solidFill>
+                <a:latin typeface="Consolas"/>
+              </a:rPr>
+              <a:t>  delta = ~0.016 sec (1/60)</a:t>
+            </a:r>
+          </a:p>
+          <a:p>
+            <a:pPr algn="ctr">
+              <a:spcAft>
+                <a:spcPts val="200"/>
+              </a:spcAft>
+            </a:pPr>
+            <a:r>
+              <a:rPr sz="1000" b="0">
+                <a:solidFill>
+                  <a:srgbClr val="AAAABB"/>
+                </a:solidFill>
+                <a:latin typeface="Consolas"/>
+              </a:rPr>
+              <a:t>At 30 FPS:</a:t>
+            </a:r>
+          </a:p>
+          <a:p>
+            <a:pPr algn="ctr">
+              <a:spcAft>
+                <a:spcPts val="200"/>
+              </a:spcAft>
+            </a:pPr>
+            <a:r>
+              <a:rPr sz="1000" b="0">
+                <a:solidFill>
+                  <a:srgbClr val="50B0C0"/>
+                </a:solidFill>
+                <a:latin typeface="Consolas"/>
+              </a:rPr>
+              <a:t>  delta = ~0.033 sec (1/30)</a:t>
+            </a:r>
+          </a:p>
+          <a:p>
+            <a:pPr algn="ctr">
+              <a:spcAft>
+                <a:spcPts val="200"/>
+              </a:spcAft>
+            </a:pPr>
+            <a:r>
+              <a:rPr sz="400" b="0">
+                <a:solidFill>
+                  <a:srgbClr val="888899"/>
+                </a:solidFill>
+                <a:latin typeface="Consolas"/>
+              </a:rPr>
+              <a:t/>
+            </a:r>
+          </a:p>
+          <a:p>
+            <a:pPr algn="ctr">
+              <a:spcAft>
+                <a:spcPts val="200"/>
+              </a:spcAft>
+            </a:pPr>
+            <a:r>
+              <a:rPr sz="1000" b="0">
+                <a:solidFill>
+                  <a:srgbClr val="FFFFFF"/>
+                </a:solidFill>
+                <a:latin typeface="Consolas"/>
+              </a:rPr>
+              <a:t>Why use it? So the game runs</a:t>
+            </a:r>
+          </a:p>
+          <a:p>
+            <a:pPr algn="ctr">
+              <a:spcAft>
+                <a:spcPts val="200"/>
+              </a:spcAft>
+            </a:pPr>
+            <a:r>
+              <a:rPr sz="1000" b="0">
+                <a:solidFill>
+                  <a:srgbClr val="FFFFFF"/>
+                </a:solidFill>
+                <a:latin typeface="Consolas"/>
+              </a:rPr>
+              <a:t>at the SAME SPEED on fast &amp;</a:t>
+            </a:r>
+          </a:p>
+          <a:p>
+            <a:pPr algn="ctr">
+              <a:spcAft>
+                <a:spcPts val="200"/>
+              </a:spcAft>
+            </a:pPr>
+            <a:r>
+              <a:rPr sz="1000" b="0">
+                <a:solidFill>
+                  <a:srgbClr val="FFFFFF"/>
+                </a:solidFill>
+                <a:latin typeface="Consolas"/>
+              </a:rPr>
+              <a:t>slow computers. Without delta,</a:t>
+            </a:r>
+          </a:p>
+          <a:p>
+            <a:pPr algn="ctr">
+              <a:spcAft>
+                <a:spcPts val="200"/>
+              </a:spcAft>
+            </a:pPr>
+            <a:r>
+              <a:rPr sz="1000" b="0">
+                <a:solidFill>
+                  <a:srgbClr val="FFFFFF"/>
+                </a:solidFill>
+                <a:latin typeface="Consolas"/>
+              </a:rPr>
+              <a:t>a faster PC = faster hunger.</a:t>
+            </a:r>
+          </a:p>
+          <a:p>
+            <a:pPr algn="ctr">
+              <a:spcAft>
+                <a:spcPts val="200"/>
+              </a:spcAft>
+            </a:pPr>
+            <a:r>
+              <a:rPr sz="400" b="0">
+                <a:solidFill>
+                  <a:srgbClr val="888899"/>
+                </a:solidFill>
+                <a:latin typeface="Consolas"/>
+              </a:rPr>
+              <a:t/>
+            </a:r>
+          </a:p>
+          <a:p>
+            <a:pPr algn="ctr">
+              <a:spcAft>
+                <a:spcPts val="200"/>
+              </a:spcAft>
+            </a:pPr>
+            <a:r>
               <a:rPr sz="900" b="0">
                 <a:solidFill>
-                  <a:srgbClr val="4FDF6F"/>
-                </a:solidFill>
-                <a:latin typeface="Consolas"/>
-              </a:rPr>
-              <a:t>Resets to 0 on eat</a:t>
-            </a:r>
-          </a:p>
-        </p:txBody>
-      </p:sp>
-      <p:sp>
-        <p:nvSpPr>
-          <p:cNvPr id="28" name="TextBox 27"/>
+                  <a:srgbClr val="FFD700"/>
+                </a:solidFill>
+                <a:latin typeface="Consolas"/>
+              </a:rPr>
+              <a:t>hunger += delta * 0.3 means:</a:t>
+            </a:r>
+          </a:p>
+          <a:p>
+            <a:pPr algn="ctr">
+              <a:spcAft>
+                <a:spcPts val="200"/>
+              </a:spcAft>
+            </a:pPr>
+            <a:r>
+              <a:rPr sz="900" b="0">
+                <a:solidFill>
+                  <a:srgbClr val="AAAABB"/>
+                </a:solidFill>
+                <a:latin typeface="Consolas"/>
+              </a:rPr>
+              <a:t>"grow hunger by 0.3 per second,</a:t>
+            </a:r>
+          </a:p>
+          <a:p>
+            <a:pPr algn="ctr">
+              <a:spcAft>
+                <a:spcPts val="200"/>
+              </a:spcAft>
+            </a:pPr>
+            <a:r>
+              <a:rPr sz="900" b="0">
+                <a:solidFill>
+                  <a:srgbClr val="AAAABB"/>
+                </a:solidFill>
+                <a:latin typeface="Consolas"/>
+              </a:rPr>
+              <a:t> regardless of frame rate."</a:t>
+            </a:r>
+          </a:p>
+        </p:txBody>
+      </p:sp>
+      <p:sp>
+        <p:nvSpPr>
+          <p:cNvPr id="35" name="TextBox 34"/>
           <p:cNvSpPr txBox="1"/>
           <p:nvPr/>
         </p:nvSpPr>
         <p:spPr>
           <a:xfrm>
-            <a:off x="274320" y="6492240"/>
+            <a:off x="274320" y="6537960"/>
             <a:ext cx="10972800" cy="274320"/>
           </a:xfrm>
           <a:prstGeom prst="rect">
@@ -4674,7 +5411,7 @@
                 </a:solidFill>
                 <a:latin typeface="Consolas"/>
               </a:rPr>
-              <a:t>ARKE: Guardians of Earth  |  rival.gd  →  do_move() lines 47-115  |  Based on CompLaB3D Research</a:t>
+              <a:t>ARKE: Guardians of Earth  |  rival.gd  |  do_move() is the brain of every rival microbe</a:t>
             </a:r>
           </a:p>
         </p:txBody>
@@ -4713,7 +5450,7 @@
         </p:nvSpPr>
         <p:spPr>
           <a:xfrm>
-            <a:off x="457200" y="137160"/>
+            <a:off x="457200" y="91440"/>
             <a:ext cx="10972800" cy="457200"/>
           </a:xfrm>
           <a:prstGeom prst="rect">
@@ -4735,7 +5472,7 @@
                 </a:solidFill>
                 <a:latin typeface="Consolas"/>
               </a:rPr>
-              <a:t>Rival AI — Code Reference with Inline Comments</a:t>
+              <a:t>Rival AI — Code Walkthrough (Line by Line)</a:t>
             </a:r>
           </a:p>
         </p:txBody>
@@ -4748,7 +5485,7 @@
         </p:nvSpPr>
         <p:spPr>
           <a:xfrm>
-            <a:off x="457200" y="548640"/>
+            <a:off x="457200" y="502920"/>
             <a:ext cx="10972800" cy="274320"/>
           </a:xfrm>
           <a:prstGeom prst="rect">
@@ -4766,11 +5503,11 @@
             <a:r>
               <a:rPr sz="1300" b="0">
                 <a:solidFill>
-                  <a:srgbClr val="888899"/>
-                </a:solidFill>
-                <a:latin typeface="Consolas"/>
-              </a:rPr>
-              <a:t>rival.gd  —  Key sections annotated</a:t>
+                  <a:srgbClr val="AAAABB"/>
+                </a:solidFill>
+                <a:latin typeface="Consolas"/>
+              </a:rPr>
+              <a:t>rival.gd  —  Each line is annotated so you can follow along</a:t>
             </a:r>
           </a:p>
         </p:txBody>
@@ -4783,14 +5520,14 @@
         </p:nvSpPr>
         <p:spPr>
           <a:xfrm>
-            <a:off x="365760" y="914400"/>
-            <a:ext cx="5577840" cy="292608"/>
+            <a:off x="365760" y="868680"/>
+            <a:ext cx="5715000" cy="384048"/>
           </a:xfrm>
           <a:prstGeom prst="roundRect">
             <a:avLst/>
           </a:prstGeom>
           <a:solidFill>
-            <a:srgbClr val="0A101A"/>
+            <a:srgbClr val="0E1220"/>
           </a:solidFill>
           <a:ln w="19050">
             <a:solidFill>
@@ -4814,7 +5551,7 @@
           </a:fontRef>
         </p:style>
         <p:txBody>
-          <a:bodyPr rtlCol="0" anchor="ctr" wrap="square"/>
+          <a:bodyPr rtlCol="0" anchor="ctr" wrap="square" lIns="101600"/>
           <a:lstStyle/>
           <a:p>
             <a:pPr algn="l"/>
@@ -4825,16 +5562,32 @@
                 </a:solidFill>
                 <a:latin typeface="Consolas"/>
               </a:rPr>
-              <a:t>  1. CONSTANTS &amp; STATE</a:t>
-            </a:r>
-            <a:r>
-              <a:rPr sz="900">
+              <a:t>  1. SETUP — Constants &amp; Variables</a:t>
+            </a:r>
+            <a:r>
+              <a:rPr sz="800">
                 <a:solidFill>
                   <a:srgbClr val="888899"/>
                 </a:solidFill>
                 <a:latin typeface="Consolas"/>
               </a:rPr>
               <a:t>    (Lines 4-17)</a:t>
+            </a:r>
+          </a:p>
+          <a:p>
+            <a:pPr algn="l">
+              <a:spcBef>
+                <a:spcPts val="0"/>
+              </a:spcBef>
+            </a:pPr>
+            <a:r>
+              <a:rPr sz="900" i="1">
+                <a:solidFill>
+                  <a:srgbClr val="AAAABB"/>
+                </a:solidFill>
+                <a:latin typeface="Consolas"/>
+              </a:rPr>
+              <a:t>    These values are set once when the rival spawns</a:t>
             </a:r>
           </a:p>
         </p:txBody>
@@ -4847,8 +5600,8 @@
         </p:nvSpPr>
         <p:spPr>
           <a:xfrm>
-            <a:off x="365760" y="1207008"/>
-            <a:ext cx="5577840" cy="877824"/>
+            <a:off x="365760" y="1252728"/>
+            <a:ext cx="5715000" cy="822960"/>
           </a:xfrm>
           <a:prstGeom prst="roundRect">
             <a:avLst/>
@@ -4886,11 +5639,11 @@
                 <a:spcPts val="100"/>
               </a:spcBef>
               <a:spcAft>
-                <a:spcPts val="100"/>
-              </a:spcAft>
-            </a:pPr>
-            <a:r>
-              <a:rPr sz="1000">
+                <a:spcPts val="0"/>
+              </a:spcAft>
+            </a:pPr>
+            <a:r>
+              <a:rPr sz="900">
                 <a:solidFill>
                   <a:srgbClr val="50B0C0"/>
                 </a:solidFill>
@@ -4899,13 +5652,13 @@
               <a:t>const SENSE_RANGE := 12</a:t>
             </a:r>
             <a:r>
-              <a:rPr sz="900">
-                <a:solidFill>
-                  <a:srgbClr val="607050"/>
-                </a:solidFill>
-                <a:latin typeface="Consolas"/>
-              </a:rPr>
-              <a:t>  # How far rival can 'smell' food (tiles)</a:t>
+              <a:rPr sz="850">
+                <a:solidFill>
+                  <a:srgbClr val="708858"/>
+                </a:solidFill>
+                <a:latin typeface="Consolas"/>
+              </a:rPr>
+              <a:t>  # The rival can 'smell' food up to 12 tiles away</a:t>
             </a:r>
           </a:p>
           <a:p>
@@ -4914,11 +5667,11 @@
                 <a:spcPts val="100"/>
               </a:spcBef>
               <a:spcAft>
-                <a:spcPts val="100"/>
-              </a:spcAft>
-            </a:pPr>
-            <a:r>
-              <a:rPr sz="1000">
+                <a:spcPts val="0"/>
+              </a:spcAft>
+            </a:pPr>
+            <a:r>
+              <a:rPr sz="900">
                 <a:solidFill>
                   <a:srgbClr val="50B0C0"/>
                 </a:solidFill>
@@ -4927,13 +5680,13 @@
               <a:t>const PLAYER_SENSE := 10</a:t>
             </a:r>
             <a:r>
-              <a:rPr sz="900">
-                <a:solidFill>
-                  <a:srgbClr val="607050"/>
-                </a:solidFill>
-                <a:latin typeface="Consolas"/>
-              </a:rPr>
-              <a:t>  # Detection radius for ARKE (tiles)</a:t>
+              <a:rPr sz="850">
+                <a:solidFill>
+                  <a:srgbClr val="708858"/>
+                </a:solidFill>
+                <a:latin typeface="Consolas"/>
+              </a:rPr>
+              <a:t>  # It can detect the player (ARKE) within 10 tiles</a:t>
             </a:r>
           </a:p>
           <a:p>
@@ -4942,11 +5695,11 @@
                 <a:spcPts val="100"/>
               </a:spcBef>
               <a:spcAft>
-                <a:spcPts val="100"/>
-              </a:spcAft>
-            </a:pPr>
-            <a:r>
-              <a:rPr sz="1000">
+                <a:spcPts val="0"/>
+              </a:spcAft>
+            </a:pPr>
+            <a:r>
+              <a:rPr sz="900">
                 <a:solidFill>
                   <a:srgbClr val="50B0C0"/>
                 </a:solidFill>
@@ -4955,13 +5708,13 @@
               <a:t>var hunger: float = 0.0</a:t>
             </a:r>
             <a:r>
-              <a:rPr sz="900">
-                <a:solidFill>
-                  <a:srgbClr val="607050"/>
-                </a:solidFill>
-                <a:latin typeface="Consolas"/>
-              </a:rPr>
-              <a:t>  # Increases over time → more aggressive</a:t>
+              <a:rPr sz="850">
+                <a:solidFill>
+                  <a:srgbClr val="708858"/>
+                </a:solidFill>
+                <a:latin typeface="Consolas"/>
+              </a:rPr>
+              <a:t>  # Starts at 0; increases every frame over time</a:t>
             </a:r>
           </a:p>
           <a:p>
@@ -4970,11 +5723,11 @@
                 <a:spcPts val="100"/>
               </a:spcBef>
               <a:spcAft>
-                <a:spcPts val="100"/>
-              </a:spcAft>
-            </a:pPr>
-            <a:r>
-              <a:rPr sz="1000">
+                <a:spcPts val="0"/>
+              </a:spcAft>
+            </a:pPr>
+            <a:r>
+              <a:rPr sz="900">
                 <a:solidFill>
                   <a:srgbClr val="50B0C0"/>
                 </a:solidFill>
@@ -4983,13 +5736,13 @@
               <a:t>var move_dir: int = 1</a:t>
             </a:r>
             <a:r>
-              <a:rPr sz="900">
-                <a:solidFill>
-                  <a:srgbClr val="607050"/>
-                </a:solidFill>
-                <a:latin typeface="Consolas"/>
-              </a:rPr>
-              <a:t>  # Preferred wander direction (1-4)</a:t>
+              <a:rPr sz="850">
+                <a:solidFill>
+                  <a:srgbClr val="708858"/>
+                </a:solidFill>
+                <a:latin typeface="Consolas"/>
+              </a:rPr>
+              <a:t>  # Its preferred wander direction (1=N, 2=E, 3=S, 4=W)</a:t>
             </a:r>
           </a:p>
         </p:txBody>
@@ -5002,14 +5755,14 @@
         </p:nvSpPr>
         <p:spPr>
           <a:xfrm>
-            <a:off x="365760" y="2157984"/>
-            <a:ext cx="5577840" cy="292608"/>
+            <a:off x="365760" y="2130552"/>
+            <a:ext cx="5715000" cy="384048"/>
           </a:xfrm>
           <a:prstGeom prst="roundRect">
             <a:avLst/>
           </a:prstGeom>
           <a:solidFill>
-            <a:srgbClr val="0A101A"/>
+            <a:srgbClr val="0E1220"/>
           </a:solidFill>
           <a:ln w="19050">
             <a:solidFill>
@@ -5033,7 +5786,7 @@
           </a:fontRef>
         </p:style>
         <p:txBody>
-          <a:bodyPr rtlCol="0" anchor="ctr" wrap="square"/>
+          <a:bodyPr rtlCol="0" anchor="ctr" wrap="square" lIns="101600"/>
           <a:lstStyle/>
           <a:p>
             <a:pPr algn="l"/>
@@ -5044,16 +5797,32 @@
                 </a:solidFill>
                 <a:latin typeface="Consolas"/>
               </a:rPr>
-              <a:t>  2. HUNGER GROWTH (every frame)</a:t>
-            </a:r>
-            <a:r>
-              <a:rPr sz="900">
+              <a:t>  2. HUNGER GROWS — Called every frame</a:t>
+            </a:r>
+            <a:r>
+              <a:rPr sz="800">
                 <a:solidFill>
                   <a:srgbClr val="888899"/>
                 </a:solidFill>
                 <a:latin typeface="Consolas"/>
               </a:rPr>
-              <a:t>    (Line 30)</a:t>
+              <a:t>    (Line 28-30)</a:t>
+            </a:r>
+          </a:p>
+          <a:p>
+            <a:pPr algn="l">
+              <a:spcBef>
+                <a:spcPts val="0"/>
+              </a:spcBef>
+            </a:pPr>
+            <a:r>
+              <a:rPr sz="900" i="1">
+                <a:solidFill>
+                  <a:srgbClr val="AAAABB"/>
+                </a:solidFill>
+                <a:latin typeface="Consolas"/>
+              </a:rPr>
+              <a:t>    delta makes this frame-rate independent (see Slide 1)</a:t>
             </a:r>
           </a:p>
         </p:txBody>
@@ -5066,8 +5835,8 @@
         </p:nvSpPr>
         <p:spPr>
           <a:xfrm>
-            <a:off x="365760" y="2450592"/>
-            <a:ext cx="5577840" cy="274320"/>
+            <a:off x="365760" y="2514600"/>
+            <a:ext cx="5715000" cy="822960"/>
           </a:xfrm>
           <a:prstGeom prst="roundRect">
             <a:avLst/>
@@ -5105,26 +5874,92 @@
                 <a:spcPts val="100"/>
               </a:spcBef>
               <a:spcAft>
+                <a:spcPts val="0"/>
+              </a:spcAft>
+            </a:pPr>
+            <a:r>
+              <a:rPr sz="900">
+                <a:solidFill>
+                  <a:srgbClr val="50B0C0"/>
+                </a:solidFill>
+                <a:latin typeface="Consolas"/>
+              </a:rPr>
+              <a:t>func _process(delta):</a:t>
+            </a:r>
+            <a:r>
+              <a:rPr sz="850">
+                <a:solidFill>
+                  <a:srgbClr val="708858"/>
+                </a:solidFill>
+                <a:latin typeface="Consolas"/>
+              </a:rPr>
+              <a:t>  # Godot calls this every single frame (~60x per sec)</a:t>
+            </a:r>
+          </a:p>
+          <a:p>
+            <a:pPr algn="l">
+              <a:spcBef>
                 <a:spcPts val="100"/>
-              </a:spcAft>
-            </a:pPr>
-            <a:r>
-              <a:rPr sz="1000">
+              </a:spcBef>
+              <a:spcAft>
+                <a:spcPts val="0"/>
+              </a:spcAft>
+            </a:pPr>
+            <a:r>
+              <a:rPr sz="900">
                 <a:solidFill>
                   <a:srgbClr val="50B0C0"/>
                 </a:solidFill>
                 <a:latin typeface="Consolas"/>
               </a:rPr>
-              <a:t>hunger += delta * 0.3</a:t>
-            </a:r>
+              <a:t>  hunger += delta * 0.3</a:t>
+            </a:r>
+            <a:r>
+              <a:rPr sz="850">
+                <a:solidFill>
+                  <a:srgbClr val="708858"/>
+                </a:solidFill>
+                <a:latin typeface="Consolas"/>
+              </a:rPr>
+              <a:t>  # delta = time since last frame (e.g. 0.016s at 60fps)</a:t>
+            </a:r>
+          </a:p>
+          <a:p>
+            <a:pPr algn="l">
+              <a:spcBef>
+                <a:spcPts val="100"/>
+              </a:spcBef>
+              <a:spcAft>
+                <a:spcPts val="0"/>
+              </a:spcAft>
+            </a:pPr>
             <a:r>
               <a:rPr sz="900">
                 <a:solidFill>
-                  <a:srgbClr val="607050"/>
-                </a:solidFill>
-                <a:latin typeface="Consolas"/>
-              </a:rPr>
-              <a:t>  # Hunger rises 0.3/sec continuously</a:t>
+                  <a:srgbClr val="50B0C0"/>
+                </a:solidFill>
+                <a:latin typeface="Consolas"/>
+              </a:rPr>
+              <a:t>  # So hunger grows by exactly 0.3 per second,</a:t>
+            </a:r>
+          </a:p>
+          <a:p>
+            <a:pPr algn="l">
+              <a:spcBef>
+                <a:spcPts val="100"/>
+              </a:spcBef>
+              <a:spcAft>
+                <a:spcPts val="0"/>
+              </a:spcAft>
+            </a:pPr>
+            <a:r>
+              <a:rPr sz="900">
+                <a:solidFill>
+                  <a:srgbClr val="50B0C0"/>
+                </a:solidFill>
+                <a:latin typeface="Consolas"/>
+              </a:rPr>
+              <a:t>  # no matter if the game runs at 30fps or 120fps.</a:t>
             </a:r>
           </a:p>
         </p:txBody>
@@ -5137,14 +5972,14 @@
         </p:nvSpPr>
         <p:spPr>
           <a:xfrm>
-            <a:off x="365760" y="2798064"/>
-            <a:ext cx="5577840" cy="292608"/>
+            <a:off x="365760" y="3392424"/>
+            <a:ext cx="5715000" cy="384048"/>
           </a:xfrm>
           <a:prstGeom prst="roundRect">
             <a:avLst/>
           </a:prstGeom>
           <a:solidFill>
-            <a:srgbClr val="0A101A"/>
+            <a:srgbClr val="0E1220"/>
           </a:solidFill>
           <a:ln w="19050">
             <a:solidFill>
@@ -5168,7 +6003,7 @@
           </a:fontRef>
         </p:style>
         <p:txBody>
-          <a:bodyPr rtlCol="0" anchor="ctr" wrap="square"/>
+          <a:bodyPr rtlCol="0" anchor="ctr" wrap="square" lIns="101600"/>
           <a:lstStyle/>
           <a:p>
             <a:pPr algn="l"/>
@@ -5179,16 +6014,32 @@
                 </a:solidFill>
                 <a:latin typeface="Consolas"/>
               </a:rPr>
-              <a:t>  3. SEEK FOOD (45-75% chance)</a:t>
-            </a:r>
-            <a:r>
-              <a:rPr sz="900">
+              <a:t>  3. SEEK FOOD — Highest priority (45-75% chance)</a:t>
+            </a:r>
+            <a:r>
+              <a:rPr sz="800">
                 <a:solidFill>
                   <a:srgbClr val="888899"/>
                 </a:solidFill>
                 <a:latin typeface="Consolas"/>
               </a:rPr>
               <a:t>    (Lines 53-64, 117-132)</a:t>
+            </a:r>
+          </a:p>
+          <a:p>
+            <a:pPr algn="l">
+              <a:spcBef>
+                <a:spcPts val="0"/>
+              </a:spcBef>
+            </a:pPr>
+            <a:r>
+              <a:rPr sz="900" i="1">
+                <a:solidFill>
+                  <a:srgbClr val="AAAABB"/>
+                </a:solidFill>
+                <a:latin typeface="Consolas"/>
+              </a:rPr>
+              <a:t>    The hungrier the rival, the more likely it picks this</a:t>
             </a:r>
           </a:p>
         </p:txBody>
@@ -5201,8 +6052,8 @@
         </p:nvSpPr>
         <p:spPr>
           <a:xfrm>
-            <a:off x="365760" y="3090672"/>
-            <a:ext cx="5577840" cy="1682496"/>
+            <a:off x="365760" y="3776472"/>
+            <a:ext cx="5715000" cy="1737360"/>
           </a:xfrm>
           <a:prstGeom prst="roundRect">
             <a:avLst/>
@@ -5240,17 +6091,26 @@
                 <a:spcPts val="100"/>
               </a:spcBef>
               <a:spcAft>
-                <a:spcPts val="100"/>
-              </a:spcAft>
-            </a:pPr>
-            <a:r>
-              <a:rPr sz="1000">
+                <a:spcPts val="0"/>
+              </a:spcAft>
+            </a:pPr>
+            <a:r>
+              <a:rPr sz="900">
                 <a:solidFill>
                   <a:srgbClr val="50B0C0"/>
                 </a:solidFill>
                 <a:latin typeface="Consolas"/>
               </a:rPr>
               <a:t>var seek_chance = clampf(</a:t>
+            </a:r>
+            <a:r>
+              <a:rPr sz="850">
+                <a:solidFill>
+                  <a:srgbClr val="708858"/>
+                </a:solidFill>
+                <a:latin typeface="Consolas"/>
+              </a:rPr>
+              <a:t>  # Calculate the chance to seek food:</a:t>
             </a:r>
           </a:p>
           <a:p>
@@ -5259,26 +6119,26 @@
                 <a:spcPts val="100"/>
               </a:spcBef>
               <a:spcAft>
-                <a:spcPts val="100"/>
-              </a:spcAft>
-            </a:pPr>
-            <a:r>
-              <a:rPr sz="1000">
+                <a:spcPts val="0"/>
+              </a:spcAft>
+            </a:pPr>
+            <a:r>
+              <a:rPr sz="900">
                 <a:solidFill>
                   <a:srgbClr val="50B0C0"/>
                 </a:solidFill>
                 <a:latin typeface="Consolas"/>
               </a:rPr>
-              <a:t>  0.45 + hunger * 0.05, 0.45, 0.75)</a:t>
-            </a:r>
-            <a:r>
-              <a:rPr sz="900">
-                <a:solidFill>
-                  <a:srgbClr val="607050"/>
-                </a:solidFill>
-                <a:latin typeface="Consolas"/>
-              </a:rPr>
-              <a:t>  # More hungry → more likely to seek</a:t>
+              <a:t>  0.45 + hunger * 0.05,</a:t>
+            </a:r>
+            <a:r>
+              <a:rPr sz="850">
+                <a:solidFill>
+                  <a:srgbClr val="708858"/>
+                </a:solidFill>
+                <a:latin typeface="Consolas"/>
+              </a:rPr>
+              <a:t>  #   Base 45% + 5% per hunger point</a:t>
             </a:r>
           </a:p>
           <a:p>
@@ -5287,26 +6147,26 @@
                 <a:spcPts val="100"/>
               </a:spcBef>
               <a:spcAft>
-                <a:spcPts val="100"/>
-              </a:spcAft>
-            </a:pPr>
-            <a:r>
-              <a:rPr sz="1000">
+                <a:spcPts val="0"/>
+              </a:spcAft>
+            </a:pPr>
+            <a:r>
+              <a:rPr sz="900">
                 <a:solidFill>
                   <a:srgbClr val="50B0C0"/>
                 </a:solidFill>
                 <a:latin typeface="Consolas"/>
               </a:rPr>
-              <a:t>if roll &lt; seek_chance:</a:t>
-            </a:r>
-            <a:r>
-              <a:rPr sz="900">
-                <a:solidFill>
-                  <a:srgbClr val="607050"/>
-                </a:solidFill>
-                <a:latin typeface="Consolas"/>
-              </a:rPr>
-              <a:t>  # Random roll decides behavior</a:t>
+              <a:t>  0.45, 0.75)</a:t>
+            </a:r>
+            <a:r>
+              <a:rPr sz="850">
+                <a:solidFill>
+                  <a:srgbClr val="708858"/>
+                </a:solidFill>
+                <a:latin typeface="Consolas"/>
+              </a:rPr>
+              <a:t>  #   But never below 45% or above 75%</a:t>
             </a:r>
           </a:p>
           <a:p>
@@ -5315,26 +6175,26 @@
                 <a:spcPts val="100"/>
               </a:spcBef>
               <a:spcAft>
-                <a:spcPts val="100"/>
-              </a:spcAft>
-            </a:pPr>
-            <a:r>
-              <a:rPr sz="1000">
+                <a:spcPts val="0"/>
+              </a:spcAft>
+            </a:pPr>
+            <a:r>
+              <a:rPr sz="900">
                 <a:solidFill>
                   <a:srgbClr val="50B0C0"/>
                 </a:solidFill>
                 <a:latin typeface="Consolas"/>
               </a:rPr>
-              <a:t>  var best = _seek_substrate(subs)</a:t>
-            </a:r>
-            <a:r>
-              <a:rPr sz="900">
-                <a:solidFill>
-                  <a:srgbClr val="607050"/>
-                </a:solidFill>
-                <a:latin typeface="Consolas"/>
-              </a:rPr>
-              <a:t>  # Find nearest substrate in range</a:t>
+              <a:t>if roll &lt; seek_chance:</a:t>
+            </a:r>
+            <a:r>
+              <a:rPr sz="850">
+                <a:solidFill>
+                  <a:srgbClr val="708858"/>
+                </a:solidFill>
+                <a:latin typeface="Consolas"/>
+              </a:rPr>
+              <a:t>  # Did we roll low enough? → Go find food!</a:t>
             </a:r>
           </a:p>
           <a:p>
@@ -5343,26 +6203,26 @@
                 <a:spcPts val="100"/>
               </a:spcBef>
               <a:spcAft>
-                <a:spcPts val="100"/>
-              </a:spcAft>
-            </a:pPr>
-            <a:r>
-              <a:rPr sz="1000">
+                <a:spcPts val="0"/>
+              </a:spcAft>
+            </a:pPr>
+            <a:r>
+              <a:rPr sz="900">
                 <a:solidFill>
                   <a:srgbClr val="50B0C0"/>
                 </a:solidFill>
                 <a:latin typeface="Consolas"/>
               </a:rPr>
-              <a:t>  for s in subs:</a:t>
-            </a:r>
-            <a:r>
-              <a:rPr sz="900">
-                <a:solidFill>
-                  <a:srgbClr val="607050"/>
-                </a:solidFill>
-                <a:latin typeface="Consolas"/>
-              </a:rPr>
-              <a:t>  # Loop all substrates</a:t>
+              <a:t>  var best = _seek_substrate(subs)</a:t>
+            </a:r>
+            <a:r>
+              <a:rPr sz="850">
+                <a:solidFill>
+                  <a:srgbClr val="708858"/>
+                </a:solidFill>
+                <a:latin typeface="Consolas"/>
+              </a:rPr>
+              <a:t>  # Scan all food sources on the map</a:t>
             </a:r>
           </a:p>
           <a:p>
@@ -5371,26 +6231,26 @@
                 <a:spcPts val="100"/>
               </a:spcBef>
               <a:spcAft>
-                <a:spcPts val="100"/>
-              </a:spcAft>
-            </a:pPr>
-            <a:r>
-              <a:rPr sz="1000">
+                <a:spcPts val="0"/>
+              </a:spcAft>
+            </a:pPr>
+            <a:r>
+              <a:rPr sz="900">
                 <a:solidFill>
                   <a:srgbClr val="50B0C0"/>
                 </a:solidFill>
                 <a:latin typeface="Consolas"/>
               </a:rPr>
-              <a:t>    if dist &lt; SENSE_RANGE * T:</a:t>
-            </a:r>
-            <a:r>
-              <a:rPr sz="900">
-                <a:solidFill>
-                  <a:srgbClr val="607050"/>
-                </a:solidFill>
-                <a:latin typeface="Consolas"/>
-              </a:rPr>
-              <a:t>  # Within 12-tile smell radius?</a:t>
+              <a:t>  for s in subs:</a:t>
+            </a:r>
+            <a:r>
+              <a:rPr sz="850">
+                <a:solidFill>
+                  <a:srgbClr val="708858"/>
+                </a:solidFill>
+                <a:latin typeface="Consolas"/>
+              </a:rPr>
+              <a:t>  # Loop through each food item one by one</a:t>
             </a:r>
           </a:p>
           <a:p>
@@ -5399,26 +6259,26 @@
                 <a:spcPts val="100"/>
               </a:spcBef>
               <a:spcAft>
-                <a:spcPts val="100"/>
-              </a:spcAft>
-            </a:pPr>
-            <a:r>
-              <a:rPr sz="1000">
+                <a:spcPts val="0"/>
+              </a:spcAft>
+            </a:pPr>
+            <a:r>
+              <a:rPr sz="900">
                 <a:solidFill>
                   <a:srgbClr val="50B0C0"/>
                 </a:solidFill>
                 <a:latin typeface="Consolas"/>
               </a:rPr>
-              <a:t>      best_pos = s.position</a:t>
-            </a:r>
-            <a:r>
-              <a:rPr sz="900">
-                <a:solidFill>
-                  <a:srgbClr val="607050"/>
-                </a:solidFill>
-                <a:latin typeface="Consolas"/>
-              </a:rPr>
-              <a:t>  # Remember closest one</a:t>
+              <a:t>    if dist &lt; SENSE_RANGE * T:</a:t>
+            </a:r>
+            <a:r>
+              <a:rPr sz="850">
+                <a:solidFill>
+                  <a:srgbClr val="708858"/>
+                </a:solidFill>
+                <a:latin typeface="Consolas"/>
+              </a:rPr>
+              <a:t>  # Is this food within our 12-tile smell range?</a:t>
             </a:r>
           </a:p>
           <a:p>
@@ -5427,26 +6287,54 @@
                 <a:spcPts val="100"/>
               </a:spcBef>
               <a:spcAft>
+                <a:spcPts val="0"/>
+              </a:spcAft>
+            </a:pPr>
+            <a:r>
+              <a:rPr sz="900">
+                <a:solidFill>
+                  <a:srgbClr val="50B0C0"/>
+                </a:solidFill>
+                <a:latin typeface="Consolas"/>
+              </a:rPr>
+              <a:t>      best_pos = s.position</a:t>
+            </a:r>
+            <a:r>
+              <a:rPr sz="850">
+                <a:solidFill>
+                  <a:srgbClr val="708858"/>
+                </a:solidFill>
+                <a:latin typeface="Consolas"/>
+              </a:rPr>
+              <a:t>  # Yes — remember it as the closest food</a:t>
+            </a:r>
+          </a:p>
+          <a:p>
+            <a:pPr algn="l">
+              <a:spcBef>
                 <a:spcPts val="100"/>
-              </a:spcAft>
-            </a:pPr>
-            <a:r>
-              <a:rPr sz="1000">
+              </a:spcBef>
+              <a:spcAft>
+                <a:spcPts val="0"/>
+              </a:spcAft>
+            </a:pPr>
+            <a:r>
+              <a:rPr sz="900">
                 <a:solidFill>
                   <a:srgbClr val="50B0C0"/>
                 </a:solidFill>
                 <a:latin typeface="Consolas"/>
               </a:rPr>
-              <a:t>  return _step_toward(dx, dy)</a:t>
-            </a:r>
-            <a:r>
-              <a:rPr sz="900">
-                <a:solidFill>
-                  <a:srgbClr val="607050"/>
-                </a:solidFill>
-                <a:latin typeface="Consolas"/>
-              </a:rPr>
-              <a:t>  # Move one tile toward food</a:t>
+              <a:t>  return _step_toward(best_pos)</a:t>
+            </a:r>
+            <a:r>
+              <a:rPr sz="850">
+                <a:solidFill>
+                  <a:srgbClr val="708858"/>
+                </a:solidFill>
+                <a:latin typeface="Consolas"/>
+              </a:rPr>
+              <a:t>  # Move one tile closer to that food</a:t>
             </a:r>
           </a:p>
         </p:txBody>
@@ -5459,14 +6347,14 @@
         </p:nvSpPr>
         <p:spPr>
           <a:xfrm>
-            <a:off x="365760" y="4846320"/>
-            <a:ext cx="5577840" cy="292608"/>
+            <a:off x="365760" y="5568696"/>
+            <a:ext cx="5715000" cy="384048"/>
           </a:xfrm>
           <a:prstGeom prst="roundRect">
             <a:avLst/>
           </a:prstGeom>
           <a:solidFill>
-            <a:srgbClr val="0A101A"/>
+            <a:srgbClr val="0E1220"/>
           </a:solidFill>
           <a:ln w="19050">
             <a:solidFill>
@@ -5490,7 +6378,7 @@
           </a:fontRef>
         </p:style>
         <p:txBody>
-          <a:bodyPr rtlCol="0" anchor="ctr" wrap="square"/>
+          <a:bodyPr rtlCol="0" anchor="ctr" wrap="square" lIns="101600"/>
           <a:lstStyle/>
           <a:p>
             <a:pPr algn="l"/>
@@ -5501,16 +6389,32 @@
                 </a:solidFill>
                 <a:latin typeface="Consolas"/>
               </a:rPr>
-              <a:t>  4. TRACK ARKE (15% chance)</a:t>
-            </a:r>
-            <a:r>
-              <a:rPr sz="900">
+              <a:t>  4. TRACK ARKE — Chase the player (15% chance)</a:t>
+            </a:r>
+            <a:r>
+              <a:rPr sz="800">
                 <a:solidFill>
                   <a:srgbClr val="888899"/>
                 </a:solidFill>
                 <a:latin typeface="Consolas"/>
               </a:rPr>
               <a:t>    (Lines 67-80)</a:t>
+            </a:r>
+          </a:p>
+          <a:p>
+            <a:pPr algn="l">
+              <a:spcBef>
+                <a:spcPts val="0"/>
+              </a:spcBef>
+            </a:pPr>
+            <a:r>
+              <a:rPr sz="900" i="1">
+                <a:solidFill>
+                  <a:srgbClr val="AAAABB"/>
+                </a:solidFill>
+                <a:latin typeface="Consolas"/>
+              </a:rPr>
+              <a:t>    Only happens if the player is close enough to notice</a:t>
             </a:r>
           </a:p>
         </p:txBody>
@@ -5523,8 +6427,8 @@
         </p:nvSpPr>
         <p:spPr>
           <a:xfrm>
-            <a:off x="365760" y="5138928"/>
-            <a:ext cx="5577840" cy="877824"/>
+            <a:off x="365760" y="5952744"/>
+            <a:ext cx="5715000" cy="1005840"/>
           </a:xfrm>
           <a:prstGeom prst="roundRect">
             <a:avLst/>
@@ -5562,26 +6466,26 @@
                 <a:spcPts val="100"/>
               </a:spcBef>
               <a:spcAft>
-                <a:spcPts val="100"/>
-              </a:spcAft>
-            </a:pPr>
-            <a:r>
-              <a:rPr sz="1000">
+                <a:spcPts val="0"/>
+              </a:spcAft>
+            </a:pPr>
+            <a:r>
+              <a:rPr sz="900">
                 <a:solidFill>
                   <a:srgbClr val="50B0C0"/>
                 </a:solidFill>
                 <a:latin typeface="Consolas"/>
               </a:rPr>
-              <a:t>if roll &lt; seek_chance + 0.15:</a:t>
-            </a:r>
-            <a:r>
-              <a:rPr sz="900">
-                <a:solidFill>
-                  <a:srgbClr val="607050"/>
-                </a:solidFill>
-                <a:latin typeface="Consolas"/>
-              </a:rPr>
-              <a:t>  # 15% chance to chase player</a:t>
+              <a:t>elif roll &lt; seek_chance + 0.15:</a:t>
+            </a:r>
+            <a:r>
+              <a:rPr sz="850">
+                <a:solidFill>
+                  <a:srgbClr val="708858"/>
+                </a:solidFill>
+                <a:latin typeface="Consolas"/>
+              </a:rPr>
+              <a:t>  # Extra 15% chance to chase the player instead</a:t>
             </a:r>
           </a:p>
           <a:p>
@@ -5590,26 +6494,26 @@
                 <a:spcPts val="100"/>
               </a:spcBef>
               <a:spcAft>
-                <a:spcPts val="100"/>
-              </a:spcAft>
-            </a:pPr>
-            <a:r>
-              <a:rPr sz="1000">
+                <a:spcPts val="0"/>
+              </a:spcAft>
+            </a:pPr>
+            <a:r>
+              <a:rPr sz="900">
                 <a:solidFill>
                   <a:srgbClr val="50B0C0"/>
                 </a:solidFill>
                 <a:latin typeface="Consolas"/>
               </a:rPr>
-              <a:t>  if absi(dx)+absi(dy) &lt; PLAYER_SENSE:</a:t>
-            </a:r>
-            <a:r>
-              <a:rPr sz="900">
-                <a:solidFill>
-                  <a:srgbClr val="607050"/>
-                </a:solidFill>
-                <a:latin typeface="Consolas"/>
-              </a:rPr>
-              <a:t>  # Player within 10 tiles?</a:t>
+              <a:t>  var dx = player.tile_x - tile_x</a:t>
+            </a:r>
+            <a:r>
+              <a:rPr sz="850">
+                <a:solidFill>
+                  <a:srgbClr val="708858"/>
+                </a:solidFill>
+                <a:latin typeface="Consolas"/>
+              </a:rPr>
+              <a:t>  # How far away is ARKE horizontally?</a:t>
             </a:r>
           </a:p>
           <a:p>
@@ -5618,26 +6522,26 @@
                 <a:spcPts val="100"/>
               </a:spcBef>
               <a:spcAft>
-                <a:spcPts val="100"/>
-              </a:spcAft>
-            </a:pPr>
-            <a:r>
-              <a:rPr sz="1000">
+                <a:spcPts val="0"/>
+              </a:spcAft>
+            </a:pPr>
+            <a:r>
+              <a:rPr sz="900">
                 <a:solidFill>
                   <a:srgbClr val="50B0C0"/>
                 </a:solidFill>
                 <a:latin typeface="Consolas"/>
               </a:rPr>
-              <a:t>    var toward = _step_toward(dx, dy)</a:t>
-            </a:r>
-            <a:r>
-              <a:rPr sz="900">
-                <a:solidFill>
-                  <a:srgbClr val="607050"/>
-                </a:solidFill>
-                <a:latin typeface="Consolas"/>
-              </a:rPr>
-              <a:t>  # Move toward ARKE's position</a:t>
+              <a:t>  var dy = player.tile_y - tile_y</a:t>
+            </a:r>
+            <a:r>
+              <a:rPr sz="850">
+                <a:solidFill>
+                  <a:srgbClr val="708858"/>
+                </a:solidFill>
+                <a:latin typeface="Consolas"/>
+              </a:rPr>
+              <a:t>  # How far away is ARKE vertically?</a:t>
             </a:r>
           </a:p>
           <a:p>
@@ -5646,26 +6550,54 @@
                 <a:spcPts val="100"/>
               </a:spcBef>
               <a:spcAft>
+                <a:spcPts val="0"/>
+              </a:spcAft>
+            </a:pPr>
+            <a:r>
+              <a:rPr sz="900">
+                <a:solidFill>
+                  <a:srgbClr val="50B0C0"/>
+                </a:solidFill>
+                <a:latin typeface="Consolas"/>
+              </a:rPr>
+              <a:t>  if absi(dx)+absi(dy) &lt; PLAYER_SENSE:</a:t>
+            </a:r>
+            <a:r>
+              <a:rPr sz="850">
+                <a:solidFill>
+                  <a:srgbClr val="708858"/>
+                </a:solidFill>
+                <a:latin typeface="Consolas"/>
+              </a:rPr>
+              <a:t>  # Total distance &lt; 10 tiles? Player is detected!</a:t>
+            </a:r>
+          </a:p>
+          <a:p>
+            <a:pPr algn="l">
+              <a:spcBef>
                 <a:spcPts val="100"/>
-              </a:spcAft>
-            </a:pPr>
-            <a:r>
-              <a:rPr sz="1000">
+              </a:spcBef>
+              <a:spcAft>
+                <a:spcPts val="0"/>
+              </a:spcAft>
+            </a:pPr>
+            <a:r>
+              <a:rPr sz="900">
                 <a:solidFill>
                   <a:srgbClr val="50B0C0"/>
                 </a:solidFill>
                 <a:latin typeface="Consolas"/>
               </a:rPr>
-              <a:t>    _move_to(ntx, nty)</a:t>
-            </a:r>
-            <a:r>
-              <a:rPr sz="900">
-                <a:solidFill>
-                  <a:srgbClr val="607050"/>
-                </a:solidFill>
-                <a:latin typeface="Consolas"/>
-              </a:rPr>
-              <a:t>  # Execute the move</a:t>
+              <a:t>    _step_toward(dx, dy)</a:t>
+            </a:r>
+            <a:r>
+              <a:rPr sz="850">
+                <a:solidFill>
+                  <a:srgbClr val="708858"/>
+                </a:solidFill>
+                <a:latin typeface="Consolas"/>
+              </a:rPr>
+              <a:t>  # Move one step toward ARKE's position</a:t>
             </a:r>
           </a:p>
         </p:txBody>
@@ -5678,14 +6610,14 @@
         </p:nvSpPr>
         <p:spPr>
           <a:xfrm>
-            <a:off x="6217920" y="914400"/>
-            <a:ext cx="5577840" cy="292608"/>
+            <a:off x="6263640" y="868680"/>
+            <a:ext cx="5715000" cy="384048"/>
           </a:xfrm>
           <a:prstGeom prst="roundRect">
             <a:avLst/>
           </a:prstGeom>
           <a:solidFill>
-            <a:srgbClr val="0A101A"/>
+            <a:srgbClr val="0E1220"/>
           </a:solidFill>
           <a:ln w="19050">
             <a:solidFill>
@@ -5709,7 +6641,7 @@
           </a:fontRef>
         </p:style>
         <p:txBody>
-          <a:bodyPr rtlCol="0" anchor="ctr" wrap="square"/>
+          <a:bodyPr rtlCol="0" anchor="ctr" wrap="square" lIns="101600"/>
           <a:lstStyle/>
           <a:p>
             <a:pPr algn="l"/>
@@ -5720,16 +6652,32 @@
                 </a:solidFill>
                 <a:latin typeface="Consolas"/>
               </a:rPr>
-              <a:t>  5. RIDE FLOW (40% when available)</a:t>
-            </a:r>
-            <a:r>
-              <a:rPr sz="900">
+              <a:t>  5. RIDE FLOW — Drift with the current (40% chance)</a:t>
+            </a:r>
+            <a:r>
+              <a:rPr sz="800">
                 <a:solidFill>
                   <a:srgbClr val="888899"/>
                 </a:solidFill>
                 <a:latin typeface="Consolas"/>
               </a:rPr>
               <a:t>    (Lines 86-96)</a:t>
+            </a:r>
+          </a:p>
+          <a:p>
+            <a:pPr algn="l">
+              <a:spcBef>
+                <a:spcPts val="0"/>
+              </a:spcBef>
+            </a:pPr>
+            <a:r>
+              <a:rPr sz="900" i="1">
+                <a:solidFill>
+                  <a:srgbClr val="AAAABB"/>
+                </a:solidFill>
+                <a:latin typeface="Consolas"/>
+              </a:rPr>
+              <a:t>    Only available if the tile has a water current</a:t>
             </a:r>
           </a:p>
         </p:txBody>
@@ -5742,8 +6690,8 @@
         </p:nvSpPr>
         <p:spPr>
           <a:xfrm>
-            <a:off x="6217920" y="1207008"/>
-            <a:ext cx="5577840" cy="877824"/>
+            <a:off x="6263640" y="1252728"/>
+            <a:ext cx="5715000" cy="1188720"/>
           </a:xfrm>
           <a:prstGeom prst="roundRect">
             <a:avLst/>
@@ -5781,26 +6729,26 @@
                 <a:spcPts val="100"/>
               </a:spcBef>
               <a:spcAft>
-                <a:spcPts val="100"/>
-              </a:spcAft>
-            </a:pPr>
-            <a:r>
-              <a:rPr sz="1000">
+                <a:spcPts val="0"/>
+              </a:spcAft>
+            </a:pPr>
+            <a:r>
+              <a:rPr sz="900">
                 <a:solidFill>
                   <a:srgbClr val="50B0C0"/>
                 </a:solidFill>
                 <a:latin typeface="Consolas"/>
               </a:rPr>
-              <a:t>var flow = world_ref.get_flow(tile_x, tile_y)</a:t>
-            </a:r>
-            <a:r>
-              <a:rPr sz="900">
-                <a:solidFill>
-                  <a:srgbClr val="607050"/>
-                </a:solidFill>
-                <a:latin typeface="Consolas"/>
-              </a:rPr>
-              <a:t>  # Get flow at current tile</a:t>
+              <a:t>var flow = world_ref.get_flow(</a:t>
+            </a:r>
+            <a:r>
+              <a:rPr sz="850">
+                <a:solidFill>
+                  <a:srgbClr val="708858"/>
+                </a:solidFill>
+                <a:latin typeface="Consolas"/>
+              </a:rPr>
+              <a:t>  # Ask the world: 'Is there a current at my tile?'</a:t>
             </a:r>
           </a:p>
           <a:p>
@@ -5809,26 +6757,26 @@
                 <a:spcPts val="100"/>
               </a:spcBef>
               <a:spcAft>
-                <a:spcPts val="100"/>
-              </a:spcAft>
-            </a:pPr>
-            <a:r>
-              <a:rPr sz="1000">
+                <a:spcPts val="0"/>
+              </a:spcAft>
+            </a:pPr>
+            <a:r>
+              <a:rPr sz="900">
                 <a:solidFill>
                   <a:srgbClr val="50B0C0"/>
                 </a:solidFill>
                 <a:latin typeface="Consolas"/>
               </a:rPr>
-              <a:t>if flow['speed'] &gt; 0.1 and randf() &lt; 0.4:</a:t>
-            </a:r>
-            <a:r>
-              <a:rPr sz="900">
-                <a:solidFill>
-                  <a:srgbClr val="607050"/>
-                </a:solidFill>
-                <a:latin typeface="Consolas"/>
-              </a:rPr>
-              <a:t>  # Flow exists + 40% chance</a:t>
+              <a:t>  tile_x, tile_y)</a:t>
+            </a:r>
+            <a:r>
+              <a:rPr sz="850">
+                <a:solidFill>
+                  <a:srgbClr val="708858"/>
+                </a:solidFill>
+                <a:latin typeface="Consolas"/>
+              </a:rPr>
+              <a:t>  # Returns {dir: N/S/E/W, speed: 0.0-1.0}</a:t>
             </a:r>
           </a:p>
           <a:p>
@@ -5837,26 +6785,26 @@
                 <a:spcPts val="100"/>
               </a:spcBef>
               <a:spcAft>
-                <a:spcPts val="100"/>
-              </a:spcAft>
-            </a:pPr>
-            <a:r>
-              <a:rPr sz="1000">
+                <a:spcPts val="0"/>
+              </a:spcAft>
+            </a:pPr>
+            <a:r>
+              <a:rPr sz="900">
                 <a:solidFill>
                   <a:srgbClr val="50B0C0"/>
                 </a:solidFill>
                 <a:latin typeface="Consolas"/>
               </a:rPr>
-              <a:t>  var fd = flow_dirs[flow['dir']]</a:t>
-            </a:r>
-            <a:r>
-              <a:rPr sz="900">
-                <a:solidFill>
-                  <a:srgbClr val="607050"/>
-                </a:solidFill>
-                <a:latin typeface="Consolas"/>
-              </a:rPr>
-              <a:t>  # Get flow direction vector</a:t>
+              <a:t>if flow['speed'] &gt; 0.1</a:t>
+            </a:r>
+            <a:r>
+              <a:rPr sz="850">
+                <a:solidFill>
+                  <a:srgbClr val="708858"/>
+                </a:solidFill>
+                <a:latin typeface="Consolas"/>
+              </a:rPr>
+              <a:t>  # Is the current strong enough? (&gt; 10% speed)</a:t>
             </a:r>
           </a:p>
           <a:p>
@@ -5865,26 +6813,82 @@
                 <a:spcPts val="100"/>
               </a:spcBef>
               <a:spcAft>
+                <a:spcPts val="0"/>
+              </a:spcAft>
+            </a:pPr>
+            <a:r>
+              <a:rPr sz="900">
+                <a:solidFill>
+                  <a:srgbClr val="50B0C0"/>
+                </a:solidFill>
+                <a:latin typeface="Consolas"/>
+              </a:rPr>
+              <a:t>   and randf() &lt; 0.4:</a:t>
+            </a:r>
+            <a:r>
+              <a:rPr sz="850">
+                <a:solidFill>
+                  <a:srgbClr val="708858"/>
+                </a:solidFill>
+                <a:latin typeface="Consolas"/>
+              </a:rPr>
+              <a:t>  # AND a 40% random chance — not always drifting</a:t>
+            </a:r>
+          </a:p>
+          <a:p>
+            <a:pPr algn="l">
+              <a:spcBef>
                 <a:spcPts val="100"/>
-              </a:spcAft>
-            </a:pPr>
-            <a:r>
-              <a:rPr sz="1000">
+              </a:spcBef>
+              <a:spcAft>
+                <a:spcPts val="0"/>
+              </a:spcAft>
+            </a:pPr>
+            <a:r>
+              <a:rPr sz="900">
                 <a:solidFill>
                   <a:srgbClr val="50B0C0"/>
                 </a:solidFill>
                 <a:latin typeface="Consolas"/>
               </a:rPr>
-              <a:t>  _move_to(tile_x + fd.x, tile_y + fd.y)</a:t>
-            </a:r>
+              <a:t>  var fd = flow_dirs[flow['dir']]</a:t>
+            </a:r>
+            <a:r>
+              <a:rPr sz="850">
+                <a:solidFill>
+                  <a:srgbClr val="708858"/>
+                </a:solidFill>
+                <a:latin typeface="Consolas"/>
+              </a:rPr>
+              <a:t>  # Convert 'North' → Vector2(0, -1) etc.</a:t>
+            </a:r>
+          </a:p>
+          <a:p>
+            <a:pPr algn="l">
+              <a:spcBef>
+                <a:spcPts val="100"/>
+              </a:spcBef>
+              <a:spcAft>
+                <a:spcPts val="0"/>
+              </a:spcAft>
+            </a:pPr>
             <a:r>
               <a:rPr sz="900">
                 <a:solidFill>
-                  <a:srgbClr val="607050"/>
-                </a:solidFill>
-                <a:latin typeface="Consolas"/>
-              </a:rPr>
-              <a:t>  # Ride the current</a:t>
+                  <a:srgbClr val="50B0C0"/>
+                </a:solidFill>
+                <a:latin typeface="Consolas"/>
+              </a:rPr>
+              <a:t>  _move_to(tile_x+fd.x, tile_y+fd.y)</a:t>
+            </a:r>
+            <a:r>
+              <a:rPr sz="850">
+                <a:solidFill>
+                  <a:srgbClr val="708858"/>
+                </a:solidFill>
+                <a:latin typeface="Consolas"/>
+              </a:rPr>
+              <a:t>  # Move one tile in the flow direction</a:t>
             </a:r>
           </a:p>
         </p:txBody>
@@ -5897,14 +6901,14 @@
         </p:nvSpPr>
         <p:spPr>
           <a:xfrm>
-            <a:off x="6217920" y="2157984"/>
-            <a:ext cx="5577840" cy="292608"/>
+            <a:off x="6263640" y="2496312"/>
+            <a:ext cx="5715000" cy="384048"/>
           </a:xfrm>
           <a:prstGeom prst="roundRect">
             <a:avLst/>
           </a:prstGeom>
           <a:solidFill>
-            <a:srgbClr val="0A101A"/>
+            <a:srgbClr val="0E1220"/>
           </a:solidFill>
           <a:ln w="19050">
             <a:solidFill>
@@ -5928,7 +6932,7 @@
           </a:fontRef>
         </p:style>
         <p:txBody>
-          <a:bodyPr rtlCol="0" anchor="ctr" wrap="square"/>
+          <a:bodyPr rtlCol="0" anchor="ctr" wrap="square" lIns="101600"/>
           <a:lstStyle/>
           <a:p>
             <a:pPr algn="l"/>
@@ -5939,16 +6943,32 @@
                 </a:solidFill>
                 <a:latin typeface="Consolas"/>
               </a:rPr>
-              <a:t>  6. WANDER (fallback)</a:t>
-            </a:r>
-            <a:r>
-              <a:rPr sz="900">
+              <a:t>  6. WANDER — Last resort if nothing else triggers</a:t>
+            </a:r>
+            <a:r>
+              <a:rPr sz="800">
                 <a:solidFill>
                   <a:srgbClr val="888899"/>
                 </a:solidFill>
                 <a:latin typeface="Consolas"/>
               </a:rPr>
               <a:t>    (Lines 98-115)</a:t>
+            </a:r>
+          </a:p>
+          <a:p>
+            <a:pPr algn="l">
+              <a:spcBef>
+                <a:spcPts val="0"/>
+              </a:spcBef>
+            </a:pPr>
+            <a:r>
+              <a:rPr sz="900" i="1">
+                <a:solidFill>
+                  <a:srgbClr val="AAAABB"/>
+                </a:solidFill>
+                <a:latin typeface="Consolas"/>
+              </a:rPr>
+              <a:t>    The rival just picks a direction and walks</a:t>
             </a:r>
           </a:p>
         </p:txBody>
@@ -5961,8 +6981,8 @@
         </p:nvSpPr>
         <p:spPr>
           <a:xfrm>
-            <a:off x="6217920" y="2450592"/>
-            <a:ext cx="5577840" cy="1078992"/>
+            <a:off x="6263640" y="2880360"/>
+            <a:ext cx="5715000" cy="1371600"/>
           </a:xfrm>
           <a:prstGeom prst="roundRect">
             <a:avLst/>
@@ -6000,26 +7020,26 @@
                 <a:spcPts val="100"/>
               </a:spcBef>
               <a:spcAft>
-                <a:spcPts val="100"/>
-              </a:spcAft>
-            </a:pPr>
-            <a:r>
-              <a:rPr sz="1000">
+                <a:spcPts val="0"/>
+              </a:spcAft>
+            </a:pPr>
+            <a:r>
+              <a:rPr sz="900">
                 <a:solidFill>
                   <a:srgbClr val="50B0C0"/>
                 </a:solidFill>
                 <a:latin typeface="Consolas"/>
               </a:rPr>
-              <a:t>var preferred = dirs[move_dir - 1]</a:t>
-            </a:r>
-            <a:r>
-              <a:rPr sz="900">
-                <a:solidFill>
-                  <a:srgbClr val="607050"/>
-                </a:solidFill>
-                <a:latin typeface="Consolas"/>
-              </a:rPr>
-              <a:t>  # Try preferred direction first</a:t>
+              <a:t>var dirs = [N, E, S, W]</a:t>
+            </a:r>
+            <a:r>
+              <a:rPr sz="850">
+                <a:solidFill>
+                  <a:srgbClr val="708858"/>
+                </a:solidFill>
+                <a:latin typeface="Consolas"/>
+              </a:rPr>
+              <a:t>  # All 4 possible directions to walk</a:t>
             </a:r>
           </a:p>
           <a:p>
@@ -6028,26 +7048,26 @@
                 <a:spcPts val="100"/>
               </a:spcBef>
               <a:spcAft>
-                <a:spcPts val="100"/>
-              </a:spcAft>
-            </a:pPr>
-            <a:r>
-              <a:rPr sz="1000">
+                <a:spcPts val="0"/>
+              </a:spcAft>
+            </a:pPr>
+            <a:r>
+              <a:rPr sz="900">
                 <a:solidFill>
                   <a:srgbClr val="50B0C0"/>
                 </a:solidFill>
                 <a:latin typeface="Consolas"/>
               </a:rPr>
-              <a:t>if is_walkable_tile(get_tile(ntx, nty)):</a:t>
-            </a:r>
-            <a:r>
-              <a:rPr sz="900">
-                <a:solidFill>
-                  <a:srgbClr val="607050"/>
-                </a:solidFill>
-                <a:latin typeface="Consolas"/>
-              </a:rPr>
-              <a:t>  # Can we go that way?</a:t>
+              <a:t>var preferred = dirs[move_dir-1]</a:t>
+            </a:r>
+            <a:r>
+              <a:rPr sz="850">
+                <a:solidFill>
+                  <a:srgbClr val="708858"/>
+                </a:solidFill>
+                <a:latin typeface="Consolas"/>
+              </a:rPr>
+              <a:t>  # Start with its favorite direction</a:t>
             </a:r>
           </a:p>
           <a:p>
@@ -6056,26 +7076,26 @@
                 <a:spcPts val="100"/>
               </a:spcBef>
               <a:spcAft>
-                <a:spcPts val="100"/>
-              </a:spcAft>
-            </a:pPr>
-            <a:r>
-              <a:rPr sz="1000">
+                <a:spcPts val="0"/>
+              </a:spcAft>
+            </a:pPr>
+            <a:r>
+              <a:rPr sz="900">
                 <a:solidFill>
                   <a:srgbClr val="50B0C0"/>
                 </a:solidFill>
                 <a:latin typeface="Consolas"/>
               </a:rPr>
-              <a:t>  _move_to(ntx, nty)</a:t>
-            </a:r>
-            <a:r>
-              <a:rPr sz="900">
-                <a:solidFill>
-                  <a:srgbClr val="607050"/>
-                </a:solidFill>
-                <a:latin typeface="Consolas"/>
-              </a:rPr>
-              <a:t>  # Move there</a:t>
+              <a:t>if is_walkable_tile(preferred):</a:t>
+            </a:r>
+            <a:r>
+              <a:rPr sz="850">
+                <a:solidFill>
+                  <a:srgbClr val="708858"/>
+                </a:solidFill>
+                <a:latin typeface="Consolas"/>
+              </a:rPr>
+              <a:t>  # Is there solid ground that way?</a:t>
             </a:r>
           </a:p>
           <a:p>
@@ -6084,26 +7104,26 @@
                 <a:spcPts val="100"/>
               </a:spcBef>
               <a:spcAft>
-                <a:spcPts val="100"/>
-              </a:spcAft>
-            </a:pPr>
-            <a:r>
-              <a:rPr sz="1000">
+                <a:spcPts val="0"/>
+              </a:spcAft>
+            </a:pPr>
+            <a:r>
+              <a:rPr sz="900">
                 <a:solidFill>
                   <a:srgbClr val="50B0C0"/>
                 </a:solidFill>
                 <a:latin typeface="Consolas"/>
               </a:rPr>
-              <a:t>  if randf() &lt; 0.25: move_dir = randi(1,4)</a:t>
-            </a:r>
-            <a:r>
-              <a:rPr sz="900">
-                <a:solidFill>
-                  <a:srgbClr val="607050"/>
-                </a:solidFill>
-                <a:latin typeface="Consolas"/>
-              </a:rPr>
-              <a:t>  # 25% chance: pick new direction</a:t>
+              <a:t>  _move_to(preferred)</a:t>
+            </a:r>
+            <a:r>
+              <a:rPr sz="850">
+                <a:solidFill>
+                  <a:srgbClr val="708858"/>
+                </a:solidFill>
+                <a:latin typeface="Consolas"/>
+              </a:rPr>
+              <a:t>  # Yes — walk there</a:t>
             </a:r>
           </a:p>
           <a:p>
@@ -6112,26 +7132,82 @@
                 <a:spcPts val="100"/>
               </a:spcBef>
               <a:spcAft>
+                <a:spcPts val="0"/>
+              </a:spcAft>
+            </a:pPr>
+            <a:r>
+              <a:rPr sz="900">
+                <a:solidFill>
+                  <a:srgbClr val="50B0C0"/>
+                </a:solidFill>
+                <a:latin typeface="Consolas"/>
+              </a:rPr>
+              <a:t>  if randf() &lt; 0.25:</a:t>
+            </a:r>
+            <a:r>
+              <a:rPr sz="850">
+                <a:solidFill>
+                  <a:srgbClr val="708858"/>
+                </a:solidFill>
+                <a:latin typeface="Consolas"/>
+              </a:rPr>
+              <a:t>  # 25% chance to randomly change</a:t>
+            </a:r>
+          </a:p>
+          <a:p>
+            <a:pPr algn="l">
+              <a:spcBef>
                 <a:spcPts val="100"/>
-              </a:spcAft>
-            </a:pPr>
-            <a:r>
-              <a:rPr sz="1000">
+              </a:spcBef>
+              <a:spcAft>
+                <a:spcPts val="0"/>
+              </a:spcAft>
+            </a:pPr>
+            <a:r>
+              <a:rPr sz="900">
                 <a:solidFill>
                   <a:srgbClr val="50B0C0"/>
                 </a:solidFill>
                 <a:latin typeface="Consolas"/>
               </a:rPr>
-              <a:t># else: dirs.shuffle() and try each</a:t>
-            </a:r>
+              <a:t>    move_dir = randi_range(1,4)</a:t>
+            </a:r>
+            <a:r>
+              <a:rPr sz="850">
+                <a:solidFill>
+                  <a:srgbClr val="708858"/>
+                </a:solidFill>
+                <a:latin typeface="Consolas"/>
+              </a:rPr>
+              <a:t>  #   its favorite direction (keeps it varied)</a:t>
+            </a:r>
+          </a:p>
+          <a:p>
+            <a:pPr algn="l">
+              <a:spcBef>
+                <a:spcPts val="100"/>
+              </a:spcBef>
+              <a:spcAft>
+                <a:spcPts val="0"/>
+              </a:spcAft>
+            </a:pPr>
             <a:r>
               <a:rPr sz="900">
                 <a:solidFill>
-                  <a:srgbClr val="607050"/>
-                </a:solidFill>
-                <a:latin typeface="Consolas"/>
-              </a:rPr>
-              <a:t>  # Fallback: random walkable tile</a:t>
+                  <a:srgbClr val="50B0C0"/>
+                </a:solidFill>
+                <a:latin typeface="Consolas"/>
+              </a:rPr>
+              <a:t>else: dirs.shuffle(); try each</a:t>
+            </a:r>
+            <a:r>
+              <a:rPr sz="850">
+                <a:solidFill>
+                  <a:srgbClr val="708858"/>
+                </a:solidFill>
+                <a:latin typeface="Consolas"/>
+              </a:rPr>
+              <a:t>  # Blocked? Try random directions instead</a:t>
             </a:r>
           </a:p>
         </p:txBody>
@@ -6144,14 +7220,14 @@
         </p:nvSpPr>
         <p:spPr>
           <a:xfrm>
-            <a:off x="6217920" y="3602736"/>
-            <a:ext cx="5577840" cy="292608"/>
+            <a:off x="6263640" y="4306824"/>
+            <a:ext cx="5715000" cy="384048"/>
           </a:xfrm>
           <a:prstGeom prst="roundRect">
             <a:avLst/>
           </a:prstGeom>
           <a:solidFill>
-            <a:srgbClr val="0A101A"/>
+            <a:srgbClr val="0E1220"/>
           </a:solidFill>
           <a:ln w="19050">
             <a:solidFill>
@@ -6175,7 +7251,7 @@
           </a:fontRef>
         </p:style>
         <p:txBody>
-          <a:bodyPr rtlCol="0" anchor="ctr" wrap="square"/>
+          <a:bodyPr rtlCol="0" anchor="ctr" wrap="square" lIns="101600"/>
           <a:lstStyle/>
           <a:p>
             <a:pPr algn="l"/>
@@ -6186,16 +7262,32 @@
                 </a:solidFill>
                 <a:latin typeface="Consolas"/>
               </a:rPr>
-              <a:t>  7. HUNGER RESET</a:t>
-            </a:r>
-            <a:r>
-              <a:rPr sz="900">
+              <a:t>  7. EATING — What happens when the rival finds food</a:t>
+            </a:r>
+            <a:r>
+              <a:rPr sz="800">
                 <a:solidFill>
                   <a:srgbClr val="888899"/>
                 </a:solidFill>
                 <a:latin typeface="Consolas"/>
               </a:rPr>
-              <a:t>    (Lines 167-169)</a:t>
+              <a:t>    (Lines 167-171)</a:t>
+            </a:r>
+          </a:p>
+          <a:p>
+            <a:pPr algn="l">
+              <a:spcBef>
+                <a:spcPts val="0"/>
+              </a:spcBef>
+            </a:pPr>
+            <a:r>
+              <a:rPr sz="900" i="1">
+                <a:solidFill>
+                  <a:srgbClr val="AAAABB"/>
+                </a:solidFill>
+                <a:latin typeface="Consolas"/>
+              </a:rPr>
+              <a:t>    Resets hunger so the rival calms down</a:t>
             </a:r>
           </a:p>
         </p:txBody>
@@ -6208,8 +7300,8 @@
         </p:nvSpPr>
         <p:spPr>
           <a:xfrm>
-            <a:off x="6217920" y="3895344"/>
-            <a:ext cx="5577840" cy="676656"/>
+            <a:off x="6263640" y="4690872"/>
+            <a:ext cx="5715000" cy="1005840"/>
           </a:xfrm>
           <a:prstGeom prst="roundRect">
             <a:avLst/>
@@ -6247,11 +7339,11 @@
                 <a:spcPts val="100"/>
               </a:spcBef>
               <a:spcAft>
-                <a:spcPts val="100"/>
-              </a:spcAft>
-            </a:pPr>
-            <a:r>
-              <a:rPr sz="1000">
+                <a:spcPts val="0"/>
+              </a:spcAft>
+            </a:pPr>
+            <a:r>
+              <a:rPr sz="900">
                 <a:solidFill>
                   <a:srgbClr val="50B0C0"/>
                 </a:solidFill>
@@ -6260,13 +7352,13 @@
               <a:t>func on_eat() -&gt; void:</a:t>
             </a:r>
             <a:r>
-              <a:rPr sz="900">
-                <a:solidFill>
-                  <a:srgbClr val="607050"/>
-                </a:solidFill>
-                <a:latin typeface="Consolas"/>
-              </a:rPr>
-              <a:t>  # Called when rival eats a substrate</a:t>
+              <a:rPr sz="850">
+                <a:solidFill>
+                  <a:srgbClr val="708858"/>
+                </a:solidFill>
+                <a:latin typeface="Consolas"/>
+              </a:rPr>
+              <a:t>  # This is called when the rival reaches food</a:t>
             </a:r>
           </a:p>
           <a:p>
@@ -6275,11 +7367,11 @@
                 <a:spcPts val="100"/>
               </a:spcBef>
               <a:spcAft>
-                <a:spcPts val="100"/>
-              </a:spcAft>
-            </a:pPr>
-            <a:r>
-              <a:rPr sz="1000">
+                <a:spcPts val="0"/>
+              </a:spcAft>
+            </a:pPr>
+            <a:r>
+              <a:rPr sz="900">
                 <a:solidFill>
                   <a:srgbClr val="50B0C0"/>
                 </a:solidFill>
@@ -6288,13 +7380,13 @@
               <a:t>  eat_flash = 0.3</a:t>
             </a:r>
             <a:r>
-              <a:rPr sz="900">
-                <a:solidFill>
-                  <a:srgbClr val="607050"/>
-                </a:solidFill>
-                <a:latin typeface="Consolas"/>
-              </a:rPr>
-              <a:t>  # Visual feedback (red flash)</a:t>
+              <a:rPr sz="850">
+                <a:solidFill>
+                  <a:srgbClr val="708858"/>
+                </a:solidFill>
+                <a:latin typeface="Consolas"/>
+              </a:rPr>
+              <a:t>  # Show a red flash for 0.3 sec (visual feedback)</a:t>
             </a:r>
           </a:p>
           <a:p>
@@ -6303,26 +7395,64 @@
                 <a:spcPts val="100"/>
               </a:spcBef>
               <a:spcAft>
+                <a:spcPts val="0"/>
+              </a:spcAft>
+            </a:pPr>
+            <a:r>
+              <a:rPr sz="900">
+                <a:solidFill>
+                  <a:srgbClr val="50B0C0"/>
+                </a:solidFill>
+                <a:latin typeface="Consolas"/>
+              </a:rPr>
+              <a:t>  hunger = 0.0</a:t>
+            </a:r>
+            <a:r>
+              <a:rPr sz="850">
+                <a:solidFill>
+                  <a:srgbClr val="708858"/>
+                </a:solidFill>
+                <a:latin typeface="Consolas"/>
+              </a:rPr>
+              <a:t>  # Reset hunger to 0 → seek_chance drops to 45%</a:t>
+            </a:r>
+          </a:p>
+          <a:p>
+            <a:pPr algn="l">
+              <a:spcBef>
                 <a:spcPts val="100"/>
-              </a:spcAft>
-            </a:pPr>
-            <a:r>
-              <a:rPr sz="1000">
+              </a:spcBef>
+              <a:spcAft>
+                <a:spcPts val="0"/>
+              </a:spcAft>
+            </a:pPr>
+            <a:r>
+              <a:rPr sz="900">
                 <a:solidFill>
                   <a:srgbClr val="50B0C0"/>
                 </a:solidFill>
                 <a:latin typeface="Consolas"/>
               </a:rPr>
-              <a:t>  hunger = 0.0</a:t>
-            </a:r>
+              <a:t>  # The rival is now 'full' and more likely</a:t>
+            </a:r>
+          </a:p>
+          <a:p>
+            <a:pPr algn="l">
+              <a:spcBef>
+                <a:spcPts val="100"/>
+              </a:spcBef>
+              <a:spcAft>
+                <a:spcPts val="0"/>
+              </a:spcAft>
+            </a:pPr>
             <a:r>
               <a:rPr sz="900">
                 <a:solidFill>
-                  <a:srgbClr val="607050"/>
-                </a:solidFill>
-                <a:latin typeface="Consolas"/>
-              </a:rPr>
-              <a:t>  # Reset hunger → less aggressive</a:t>
+                  <a:srgbClr val="50B0C0"/>
+                </a:solidFill>
+                <a:latin typeface="Consolas"/>
+              </a:rPr>
+              <a:t>  # to wander or ride flow instead of seeking.</a:t>
             </a:r>
           </a:p>
         </p:txBody>
@@ -6357,7 +7487,7 @@
                 </a:solidFill>
                 <a:latin typeface="Consolas"/>
               </a:rPr>
-              <a:t>ARKE: Guardians of Earth  |  rival.gd  |  GDScript (Godot 4.2+)  |  Based on CompLaB3D Research</a:t>
+              <a:t>ARKE: Guardians of Earth  |  rival.gd  |  GDScript (Godot 4.x)  |  Read each green comment left-to-right</a:t>
             </a:r>
           </a:p>
         </p:txBody>
@@ -6396,7 +7526,7 @@
         </p:nvSpPr>
         <p:spPr>
           <a:xfrm>
-            <a:off x="457200" y="182880"/>
+            <a:off x="457200" y="137160"/>
             <a:ext cx="10972800" cy="457200"/>
           </a:xfrm>
           <a:prstGeom prst="rect">
@@ -6418,21 +7548,56 @@
                 </a:solidFill>
                 <a:latin typeface="Consolas"/>
               </a:rPr>
-              <a:t>Rival AI — Decision Priority Summary</a:t>
-            </a:r>
-          </a:p>
-        </p:txBody>
-      </p:sp>
-      <p:sp>
-        <p:nvSpPr>
-          <p:cNvPr id="3" name="Rounded Rectangle 2"/>
+              <a:t>Rival AI — The 4 Behaviors at a Glance</a:t>
+            </a:r>
+          </a:p>
+        </p:txBody>
+      </p:sp>
+      <p:sp>
+        <p:nvSpPr>
+          <p:cNvPr id="3" name="TextBox 2"/>
+          <p:cNvSpPr txBox="1"/>
+          <p:nvPr/>
+        </p:nvSpPr>
+        <p:spPr>
+          <a:xfrm>
+            <a:off x="457200" y="548640"/>
+            <a:ext cx="10972800" cy="274320"/>
+          </a:xfrm>
+          <a:prstGeom prst="rect">
+            <a:avLst/>
+          </a:prstGeom>
+          <a:noFill/>
+        </p:spPr>
+        <p:txBody>
+          <a:bodyPr wrap="square">
+            <a:spAutoFit/>
+          </a:bodyPr>
+          <a:lstStyle/>
+          <a:p>
+            <a:pPr algn="ctr"/>
+            <a:r>
+              <a:rPr sz="1400" b="0">
+                <a:solidFill>
+                  <a:srgbClr val="AAAABB"/>
+                </a:solidFill>
+                <a:latin typeface="Consolas"/>
+              </a:rPr>
+              <a:t>The rival checks these in order. The first one that passes wins.</a:t>
+            </a:r>
+          </a:p>
+        </p:txBody>
+      </p:sp>
+      <p:sp>
+        <p:nvSpPr>
+          <p:cNvPr id="4" name="Rounded Rectangle 3"/>
           <p:cNvSpPr/>
           <p:nvPr/>
         </p:nvSpPr>
         <p:spPr>
           <a:xfrm>
-            <a:off x="426567" y="1371600"/>
-            <a:ext cx="2560320" cy="2926080"/>
+            <a:off x="609447" y="1188720"/>
+            <a:ext cx="2468880" cy="3291840"/>
           </a:xfrm>
           <a:prstGeom prst="roundRect">
             <a:avLst/>
@@ -6462,7 +7627,7 @@
           </a:fontRef>
         </p:style>
         <p:txBody>
-          <a:bodyPr rtlCol="0" anchor="ctr" wrap="square" tIns="381000" lIns="152400" rIns="152400"/>
+          <a:bodyPr rtlCol="0" anchor="ctr" wrap="square" tIns="444500" lIns="152400" rIns="152400"/>
           <a:lstStyle/>
           <a:p>
             <a:pPr algn="ctr"/>
@@ -6473,55 +7638,58 @@
                 </a:solidFill>
                 <a:latin typeface="Consolas"/>
               </a:rPr>
-              <a:t>SEEK FOOD</a:t>
+              <a:t>SEEK
+FOOD</a:t>
             </a:r>
           </a:p>
           <a:p>
             <a:pPr algn="ctr">
               <a:spcBef>
-                <a:spcPts val="800"/>
+                <a:spcPts val="1000"/>
               </a:spcBef>
             </a:pPr>
             <a:r>
-              <a:rPr sz="1300" b="1">
+              <a:rPr sz="1200" b="1">
                 <a:solidFill>
                   <a:srgbClr val="FFD700"/>
                 </a:solidFill>
                 <a:latin typeface="Consolas"/>
               </a:rPr>
-              <a:t>Chance: 45–75%</a:t>
+              <a:t>Chance: 45-75%</a:t>
             </a:r>
           </a:p>
           <a:p>
             <a:pPr algn="ctr">
               <a:spcBef>
-                <a:spcPts val="1600"/>
+                <a:spcPts val="1400"/>
               </a:spcBef>
             </a:pPr>
             <a:r>
               <a:rPr sz="1000">
                 <a:solidFill>
-                  <a:srgbClr val="888899"/>
-                </a:solidFill>
-                <a:latin typeface="Consolas"/>
-              </a:rPr>
-              <a:t>Detect substrates within 12 tiles
-Hunger increases chance over time
-_seek_substrate() → _step_toward()</a:t>
-            </a:r>
-          </a:p>
-        </p:txBody>
-      </p:sp>
-      <p:sp>
-        <p:nvSpPr>
-          <p:cNvPr id="4" name="Oval 3"/>
+                  <a:srgbClr val="AAAABB"/>
+                </a:solidFill>
+                <a:latin typeface="Consolas"/>
+              </a:rPr>
+              <a:t>The rival looks for the
+closest food within 12
+tiles and walks toward it.
+Higher hunger = higher
+chance (45% up to 75%).</a:t>
+            </a:r>
+          </a:p>
+        </p:txBody>
+      </p:sp>
+      <p:sp>
+        <p:nvSpPr>
+          <p:cNvPr id="5" name="Oval 4"/>
           <p:cNvSpPr/>
           <p:nvPr/>
         </p:nvSpPr>
         <p:spPr>
           <a:xfrm>
-            <a:off x="1386687" y="1143000"/>
-            <a:ext cx="457200" cy="457200"/>
+            <a:off x="1569567" y="960120"/>
+            <a:ext cx="548640" cy="548640"/>
           </a:xfrm>
           <a:prstGeom prst="ellipse">
             <a:avLst/>
@@ -6553,7 +7721,7 @@
           <a:p>
             <a:pPr algn="ctr"/>
             <a:r>
-              <a:rPr sz="1800" b="1">
+              <a:rPr sz="2000" b="1">
                 <a:solidFill>
                   <a:srgbClr val="0A0E1A"/>
                 </a:solidFill>
@@ -6566,14 +7734,14 @@
       </p:sp>
       <p:sp>
         <p:nvSpPr>
-          <p:cNvPr id="5" name="TextBox 4"/>
+          <p:cNvPr id="6" name="TextBox 5"/>
           <p:cNvSpPr txBox="1"/>
           <p:nvPr/>
         </p:nvSpPr>
         <p:spPr>
           <a:xfrm>
-            <a:off x="3032607" y="2697480"/>
-            <a:ext cx="274320" cy="274320"/>
+            <a:off x="3096615" y="2697480"/>
+            <a:ext cx="320040" cy="320040"/>
           </a:xfrm>
           <a:prstGeom prst="rect">
             <a:avLst/>
@@ -6588,27 +7756,27 @@
           <a:p>
             <a:pPr algn="ctr"/>
             <a:r>
-              <a:rPr sz="2000" b="1">
+              <a:rPr sz="1600" b="1">
                 <a:solidFill>
                   <a:srgbClr val="888899"/>
                 </a:solidFill>
                 <a:latin typeface="Consolas"/>
               </a:rPr>
-              <a:t>→</a:t>
-            </a:r>
-          </a:p>
-        </p:txBody>
-      </p:sp>
-      <p:sp>
-        <p:nvSpPr>
-          <p:cNvPr id="6" name="Rounded Rectangle 5"/>
+              <a:t>&gt;&gt;</a:t>
+            </a:r>
+          </a:p>
+        </p:txBody>
+      </p:sp>
+      <p:sp>
+        <p:nvSpPr>
+          <p:cNvPr id="7" name="Rounded Rectangle 6"/>
           <p:cNvSpPr/>
           <p:nvPr/>
         </p:nvSpPr>
         <p:spPr>
           <a:xfrm>
-            <a:off x="3352647" y="1371600"/>
-            <a:ext cx="2560320" cy="2926080"/>
+            <a:off x="3444087" y="1188720"/>
+            <a:ext cx="2468880" cy="3291840"/>
           </a:xfrm>
           <a:prstGeom prst="roundRect">
             <a:avLst/>
@@ -6638,7 +7806,7 @@
           </a:fontRef>
         </p:style>
         <p:txBody>
-          <a:bodyPr rtlCol="0" anchor="ctr" wrap="square" tIns="381000" lIns="152400" rIns="152400"/>
+          <a:bodyPr rtlCol="0" anchor="ctr" wrap="square" tIns="444500" lIns="152400" rIns="152400"/>
           <a:lstStyle/>
           <a:p>
             <a:pPr algn="ctr"/>
@@ -6649,55 +7817,58 @@
                 </a:solidFill>
                 <a:latin typeface="Consolas"/>
               </a:rPr>
-              <a:t>TRACK ARKE</a:t>
+              <a:t>TRACK
+ARKE</a:t>
             </a:r>
           </a:p>
           <a:p>
             <a:pPr algn="ctr">
               <a:spcBef>
-                <a:spcPts val="800"/>
+                <a:spcPts val="1000"/>
               </a:spcBef>
             </a:pPr>
             <a:r>
-              <a:rPr sz="1300" b="1">
+              <a:rPr sz="1200" b="1">
                 <a:solidFill>
                   <a:srgbClr val="FFD700"/>
                 </a:solidFill>
                 <a:latin typeface="Consolas"/>
               </a:rPr>
-              <a:t>Chance: 15%</a:t>
+              <a:t>Chance: +15%</a:t>
             </a:r>
           </a:p>
           <a:p>
             <a:pPr algn="ctr">
               <a:spcBef>
-                <a:spcPts val="1600"/>
+                <a:spcPts val="1400"/>
               </a:spcBef>
             </a:pPr>
             <a:r>
               <a:rPr sz="1000">
                 <a:solidFill>
-                  <a:srgbClr val="888899"/>
-                </a:solidFill>
-                <a:latin typeface="Consolas"/>
-              </a:rPr>
-              <a:t>Follow player within 10 tiles
-Compete for same food zone
-_step_toward(player_pos)</a:t>
-            </a:r>
-          </a:p>
-        </p:txBody>
-      </p:sp>
-      <p:sp>
-        <p:nvSpPr>
-          <p:cNvPr id="7" name="Oval 6"/>
+                  <a:srgbClr val="AAAABB"/>
+                </a:solidFill>
+                <a:latin typeface="Consolas"/>
+              </a:rPr>
+              <a:t>If the player is within
+10 tiles, the rival may
+chase them to compete
+for the same food area.
+Only a 15% extra chance.</a:t>
+            </a:r>
+          </a:p>
+        </p:txBody>
+      </p:sp>
+      <p:sp>
+        <p:nvSpPr>
+          <p:cNvPr id="8" name="Oval 7"/>
           <p:cNvSpPr/>
           <p:nvPr/>
         </p:nvSpPr>
         <p:spPr>
           <a:xfrm>
-            <a:off x="4312767" y="1143000"/>
-            <a:ext cx="457200" cy="457200"/>
+            <a:off x="4404207" y="960120"/>
+            <a:ext cx="548640" cy="548640"/>
           </a:xfrm>
           <a:prstGeom prst="ellipse">
             <a:avLst/>
@@ -6729,7 +7900,7 @@
           <a:p>
             <a:pPr algn="ctr"/>
             <a:r>
-              <a:rPr sz="1800" b="1">
+              <a:rPr sz="2000" b="1">
                 <a:solidFill>
                   <a:srgbClr val="0A0E1A"/>
                 </a:solidFill>
@@ -6742,14 +7913,14 @@
       </p:sp>
       <p:sp>
         <p:nvSpPr>
-          <p:cNvPr id="8" name="TextBox 7"/>
+          <p:cNvPr id="9" name="TextBox 8"/>
           <p:cNvSpPr txBox="1"/>
           <p:nvPr/>
         </p:nvSpPr>
         <p:spPr>
           <a:xfrm>
-            <a:off x="5958687" y="2697480"/>
-            <a:ext cx="274320" cy="274320"/>
+            <a:off x="5931255" y="2697480"/>
+            <a:ext cx="320040" cy="320040"/>
           </a:xfrm>
           <a:prstGeom prst="rect">
             <a:avLst/>
@@ -6764,27 +7935,27 @@
           <a:p>
             <a:pPr algn="ctr"/>
             <a:r>
-              <a:rPr sz="2000" b="1">
+              <a:rPr sz="1600" b="1">
                 <a:solidFill>
                   <a:srgbClr val="888899"/>
                 </a:solidFill>
                 <a:latin typeface="Consolas"/>
               </a:rPr>
-              <a:t>→</a:t>
-            </a:r>
-          </a:p>
-        </p:txBody>
-      </p:sp>
-      <p:sp>
-        <p:nvSpPr>
-          <p:cNvPr id="9" name="Rounded Rectangle 8"/>
+              <a:t>&gt;&gt;</a:t>
+            </a:r>
+          </a:p>
+        </p:txBody>
+      </p:sp>
+      <p:sp>
+        <p:nvSpPr>
+          <p:cNvPr id="10" name="Rounded Rectangle 9"/>
           <p:cNvSpPr/>
           <p:nvPr/>
         </p:nvSpPr>
         <p:spPr>
           <a:xfrm>
-            <a:off x="6278727" y="1371600"/>
-            <a:ext cx="2560320" cy="2926080"/>
+            <a:off x="6278727" y="1188720"/>
+            <a:ext cx="2468880" cy="3291840"/>
           </a:xfrm>
           <a:prstGeom prst="roundRect">
             <a:avLst/>
@@ -6814,7 +7985,7 @@
           </a:fontRef>
         </p:style>
         <p:txBody>
-          <a:bodyPr rtlCol="0" anchor="ctr" wrap="square" tIns="381000" lIns="152400" rIns="152400"/>
+          <a:bodyPr rtlCol="0" anchor="ctr" wrap="square" tIns="444500" lIns="152400" rIns="152400"/>
           <a:lstStyle/>
           <a:p>
             <a:pPr algn="ctr"/>
@@ -6825,55 +7996,58 @@
                 </a:solidFill>
                 <a:latin typeface="Consolas"/>
               </a:rPr>
-              <a:t>RIDE FLOW</a:t>
+              <a:t>RIDE
+FLOW</a:t>
             </a:r>
           </a:p>
           <a:p>
             <a:pPr algn="ctr">
               <a:spcBef>
-                <a:spcPts val="800"/>
+                <a:spcPts val="1000"/>
               </a:spcBef>
             </a:pPr>
             <a:r>
-              <a:rPr sz="1300" b="1">
+              <a:rPr sz="1200" b="1">
                 <a:solidFill>
                   <a:srgbClr val="FFD700"/>
                 </a:solidFill>
                 <a:latin typeface="Consolas"/>
               </a:rPr>
-              <a:t>Chance: ~40%*</a:t>
+              <a:t>Chance: 40%*</a:t>
             </a:r>
           </a:p>
           <a:p>
             <a:pPr algn="ctr">
               <a:spcBef>
-                <a:spcPts val="1600"/>
+                <a:spcPts val="1400"/>
               </a:spcBef>
             </a:pPr>
             <a:r>
               <a:rPr sz="1000">
                 <a:solidFill>
-                  <a:srgbClr val="888899"/>
-                </a:solidFill>
-                <a:latin typeface="Consolas"/>
-              </a:rPr>
-              <a:t>If flow speed &gt; 0.1 at current tile
-40% chance to follow current
-Uses world pressure-driven flow field</a:t>
-            </a:r>
-          </a:p>
-        </p:txBody>
-      </p:sp>
-      <p:sp>
-        <p:nvSpPr>
-          <p:cNvPr id="10" name="Oval 9"/>
+                  <a:srgbClr val="AAAABB"/>
+                </a:solidFill>
+                <a:latin typeface="Consolas"/>
+              </a:rPr>
+              <a:t>If there is a water
+current at this tile
+(speed &gt; 0.1), the rival
+drifts with it.
+40% chance per decision.</a:t>
+            </a:r>
+          </a:p>
+        </p:txBody>
+      </p:sp>
+      <p:sp>
+        <p:nvSpPr>
+          <p:cNvPr id="11" name="Oval 10"/>
           <p:cNvSpPr/>
           <p:nvPr/>
         </p:nvSpPr>
         <p:spPr>
           <a:xfrm>
-            <a:off x="7238847" y="1143000"/>
-            <a:ext cx="457200" cy="457200"/>
+            <a:off x="7238847" y="960120"/>
+            <a:ext cx="548640" cy="548640"/>
           </a:xfrm>
           <a:prstGeom prst="ellipse">
             <a:avLst/>
@@ -6905,7 +8079,7 @@
           <a:p>
             <a:pPr algn="ctr"/>
             <a:r>
-              <a:rPr sz="1800" b="1">
+              <a:rPr sz="2000" b="1">
                 <a:solidFill>
                   <a:srgbClr val="0A0E1A"/>
                 </a:solidFill>
@@ -6918,14 +8092,14 @@
       </p:sp>
       <p:sp>
         <p:nvSpPr>
-          <p:cNvPr id="11" name="TextBox 10"/>
+          <p:cNvPr id="12" name="TextBox 11"/>
           <p:cNvSpPr txBox="1"/>
           <p:nvPr/>
         </p:nvSpPr>
         <p:spPr>
           <a:xfrm>
-            <a:off x="8884767" y="2697480"/>
-            <a:ext cx="274320" cy="274320"/>
+            <a:off x="8765895" y="2697480"/>
+            <a:ext cx="320040" cy="320040"/>
           </a:xfrm>
           <a:prstGeom prst="rect">
             <a:avLst/>
@@ -6940,27 +8114,27 @@
           <a:p>
             <a:pPr algn="ctr"/>
             <a:r>
-              <a:rPr sz="2000" b="1">
+              <a:rPr sz="1600" b="1">
                 <a:solidFill>
                   <a:srgbClr val="888899"/>
                 </a:solidFill>
                 <a:latin typeface="Consolas"/>
               </a:rPr>
-              <a:t>→</a:t>
-            </a:r>
-          </a:p>
-        </p:txBody>
-      </p:sp>
-      <p:sp>
-        <p:nvSpPr>
-          <p:cNvPr id="12" name="Rounded Rectangle 11"/>
+              <a:t>&gt;&gt;</a:t>
+            </a:r>
+          </a:p>
+        </p:txBody>
+      </p:sp>
+      <p:sp>
+        <p:nvSpPr>
+          <p:cNvPr id="13" name="Rounded Rectangle 12"/>
           <p:cNvSpPr/>
           <p:nvPr/>
         </p:nvSpPr>
         <p:spPr>
           <a:xfrm>
-            <a:off x="9204807" y="1371600"/>
-            <a:ext cx="2560320" cy="2926080"/>
+            <a:off x="9113367" y="1188720"/>
+            <a:ext cx="2468880" cy="3291840"/>
           </a:xfrm>
           <a:prstGeom prst="roundRect">
             <a:avLst/>
@@ -6990,7 +8164,7 @@
           </a:fontRef>
         </p:style>
         <p:txBody>
-          <a:bodyPr rtlCol="0" anchor="ctr" wrap="square" tIns="381000" lIns="152400" rIns="152400"/>
+          <a:bodyPr rtlCol="0" anchor="ctr" wrap="square" tIns="444500" lIns="152400" rIns="152400"/>
           <a:lstStyle/>
           <a:p>
             <a:pPr algn="ctr"/>
@@ -7007,49 +8181,52 @@
           <a:p>
             <a:pPr algn="ctr">
               <a:spcBef>
-                <a:spcPts val="800"/>
+                <a:spcPts val="1000"/>
               </a:spcBef>
             </a:pPr>
             <a:r>
-              <a:rPr sz="1300" b="1">
+              <a:rPr sz="1200" b="1">
                 <a:solidFill>
                   <a:srgbClr val="FFD700"/>
                 </a:solidFill>
                 <a:latin typeface="Consolas"/>
               </a:rPr>
-              <a:t>Chance: Fallback</a:t>
+              <a:t>Chance: Always</a:t>
             </a:r>
           </a:p>
           <a:p>
             <a:pPr algn="ctr">
               <a:spcBef>
-                <a:spcPts val="1600"/>
+                <a:spcPts val="1400"/>
               </a:spcBef>
             </a:pPr>
             <a:r>
               <a:rPr sz="1000">
                 <a:solidFill>
-                  <a:srgbClr val="888899"/>
-                </a:solidFill>
-                <a:latin typeface="Consolas"/>
-              </a:rPr>
-              <a:t>Try preferred direction first
-25% chance to change direction
-If blocked → shuffle &amp; try random</a:t>
-            </a:r>
-          </a:p>
-        </p:txBody>
-      </p:sp>
-      <p:sp>
-        <p:nvSpPr>
-          <p:cNvPr id="13" name="Oval 12"/>
+                  <a:srgbClr val="AAAABB"/>
+                </a:solidFill>
+                <a:latin typeface="Consolas"/>
+              </a:rPr>
+              <a:t>Nothing else triggered.
+Pick a direction and walk.
+Try preferred dir first;
+if blocked, shuffle and
+try any open direction.
+25% chance to change dir.</a:t>
+            </a:r>
+          </a:p>
+        </p:txBody>
+      </p:sp>
+      <p:sp>
+        <p:nvSpPr>
+          <p:cNvPr id="14" name="Oval 13"/>
           <p:cNvSpPr/>
           <p:nvPr/>
         </p:nvSpPr>
         <p:spPr>
           <a:xfrm>
-            <a:off x="10164927" y="1143000"/>
-            <a:ext cx="457200" cy="457200"/>
+            <a:off x="10073487" y="960120"/>
+            <a:ext cx="548640" cy="548640"/>
           </a:xfrm>
           <a:prstGeom prst="ellipse">
             <a:avLst/>
@@ -7081,7 +8258,7 @@
           <a:p>
             <a:pPr algn="ctr"/>
             <a:r>
-              <a:rPr sz="1800" b="1">
+              <a:rPr sz="2000" b="1">
                 <a:solidFill>
                   <a:srgbClr val="0A0E1A"/>
                 </a:solidFill>
@@ -7094,14 +8271,14 @@
       </p:sp>
       <p:sp>
         <p:nvSpPr>
-          <p:cNvPr id="14" name="TextBox 13"/>
+          <p:cNvPr id="15" name="TextBox 14"/>
           <p:cNvSpPr txBox="1"/>
           <p:nvPr/>
         </p:nvSpPr>
         <p:spPr>
           <a:xfrm>
-            <a:off x="457200" y="4754880"/>
-            <a:ext cx="10972800" cy="457200"/>
+            <a:off x="457200" y="4846320"/>
+            <a:ext cx="10972800" cy="365760"/>
           </a:xfrm>
           <a:prstGeom prst="rect">
             <a:avLst/>
@@ -7122,31 +8299,31 @@
                 </a:solidFill>
                 <a:latin typeface="Consolas"/>
               </a:rPr>
-              <a:t>* Ride Flow only triggers if the current tile has flow speed &gt; 0.1</a:t>
-            </a:r>
-          </a:p>
-        </p:txBody>
-      </p:sp>
-      <p:sp>
-        <p:nvSpPr>
-          <p:cNvPr id="15" name="Rounded Rectangle 14"/>
+              <a:t>* Ride Flow only happens when the tile actually has a water current (speed &gt; 0.1)</a:t>
+            </a:r>
+          </a:p>
+        </p:txBody>
+      </p:sp>
+      <p:sp>
+        <p:nvSpPr>
+          <p:cNvPr id="16" name="Rounded Rectangle 15"/>
           <p:cNvSpPr/>
           <p:nvPr/>
         </p:nvSpPr>
         <p:spPr>
           <a:xfrm>
-            <a:off x="3200400" y="5212080"/>
-            <a:ext cx="5760720" cy="1097280"/>
+            <a:off x="1371600" y="5212080"/>
+            <a:ext cx="9418320" cy="1280160"/>
           </a:xfrm>
           <a:prstGeom prst="roundRect">
             <a:avLst/>
           </a:prstGeom>
           <a:solidFill>
-            <a:srgbClr val="1A1010"/>
+            <a:srgbClr val="120E18"/>
           </a:solidFill>
           <a:ln w="19050">
             <a:solidFill>
-              <a:srgbClr val="E06060"/>
+              <a:srgbClr val="CF6FFF"/>
             </a:solidFill>
           </a:ln>
           <a:effectLst/>
@@ -7175,90 +8352,154 @@
               </a:spcAft>
             </a:pPr>
             <a:r>
-              <a:rPr sz="1200" b="1">
+              <a:rPr sz="1400" b="1">
+                <a:solidFill>
+                  <a:srgbClr val="CF6FFF"/>
+                </a:solidFill>
+                <a:latin typeface="Consolas"/>
+              </a:rPr>
+              <a:t>KEY CONCEPTS</a:t>
+            </a:r>
+          </a:p>
+          <a:p>
+            <a:pPr algn="ctr">
+              <a:spcAft>
+                <a:spcPts val="200"/>
+              </a:spcAft>
+            </a:pPr>
+            <a:r>
+              <a:rPr sz="300" b="0">
+                <a:solidFill>
+                  <a:srgbClr val="888899"/>
+                </a:solidFill>
+                <a:latin typeface="Consolas"/>
+              </a:rPr>
+              <a:t/>
+            </a:r>
+          </a:p>
+          <a:p>
+            <a:pPr algn="ctr">
+              <a:spcAft>
+                <a:spcPts val="200"/>
+              </a:spcAft>
+            </a:pPr>
+            <a:r>
+              <a:rPr sz="1100" b="0">
+                <a:solidFill>
+                  <a:srgbClr val="FFFFFF"/>
+                </a:solidFill>
+                <a:latin typeface="Consolas"/>
+              </a:rPr>
+              <a:t>HUNGER:  hunger += delta * 0.3  means hunger grows by 0.3 every second.</a:t>
+            </a:r>
+          </a:p>
+          <a:p>
+            <a:pPr algn="ctr">
+              <a:spcAft>
+                <a:spcPts val="200"/>
+              </a:spcAft>
+            </a:pPr>
+            <a:r>
+              <a:rPr sz="1100" b="0">
+                <a:solidFill>
+                  <a:srgbClr val="AAAABB"/>
+                </a:solidFill>
+                <a:latin typeface="Consolas"/>
+              </a:rPr>
+              <a:t>         The hungrier the rival, the more it prioritizes finding food (45% -&gt; 75%).</a:t>
+            </a:r>
+          </a:p>
+          <a:p>
+            <a:pPr algn="ctr">
+              <a:spcAft>
+                <a:spcPts val="200"/>
+              </a:spcAft>
+            </a:pPr>
+            <a:r>
+              <a:rPr sz="1100" b="0">
+                <a:solidFill>
+                  <a:srgbClr val="4FDF6F"/>
+                </a:solidFill>
+                <a:latin typeface="Consolas"/>
+              </a:rPr>
+              <a:t>         Eating food resets hunger back to 0 — the rival "calms down."</a:t>
+            </a:r>
+          </a:p>
+          <a:p>
+            <a:pPr algn="ctr">
+              <a:spcAft>
+                <a:spcPts val="200"/>
+              </a:spcAft>
+            </a:pPr>
+            <a:r>
+              <a:rPr sz="300" b="0">
+                <a:solidFill>
+                  <a:srgbClr val="888899"/>
+                </a:solidFill>
+                <a:latin typeface="Consolas"/>
+              </a:rPr>
+              <a:t/>
+            </a:r>
+          </a:p>
+          <a:p>
+            <a:pPr algn="ctr">
+              <a:spcAft>
+                <a:spcPts val="200"/>
+              </a:spcAft>
+            </a:pPr>
+            <a:r>
+              <a:rPr sz="1100" b="0">
+                <a:solidFill>
+                  <a:srgbClr val="FFFFFF"/>
+                </a:solidFill>
+                <a:latin typeface="Consolas"/>
+              </a:rPr>
+              <a:t>DELTA:   delta = seconds since the last frame.  At 60 FPS that is ~0.016 seconds.</a:t>
+            </a:r>
+          </a:p>
+          <a:p>
+            <a:pPr algn="ctr">
+              <a:spcAft>
+                <a:spcPts val="200"/>
+              </a:spcAft>
+            </a:pPr>
+            <a:r>
+              <a:rPr sz="1100" b="0">
+                <a:solidFill>
+                  <a:srgbClr val="AAAABB"/>
+                </a:solidFill>
+                <a:latin typeface="Consolas"/>
+              </a:rPr>
+              <a:t>         Multiplying by delta ensures the game behaves identically on all hardware.</a:t>
+            </a:r>
+          </a:p>
+          <a:p>
+            <a:pPr algn="ctr">
+              <a:spcAft>
+                <a:spcPts val="200"/>
+              </a:spcAft>
+            </a:pPr>
+            <a:r>
+              <a:rPr sz="1100" b="0">
                 <a:solidFill>
                   <a:srgbClr val="E06060"/>
                 </a:solidFill>
                 <a:latin typeface="Consolas"/>
               </a:rPr>
-              <a:t>HUNGER MECHANIC  (affects Priority #1)</a:t>
-            </a:r>
-          </a:p>
-          <a:p>
-            <a:pPr algn="ctr">
-              <a:spcAft>
-                <a:spcPts val="200"/>
-              </a:spcAft>
-            </a:pPr>
-            <a:r>
-              <a:rPr sz="400" b="0">
-                <a:solidFill>
-                  <a:srgbClr val="888899"/>
-                </a:solidFill>
-                <a:latin typeface="Consolas"/>
-              </a:rPr>
-              <a:t/>
-            </a:r>
-          </a:p>
-          <a:p>
-            <a:pPr algn="ctr">
-              <a:spcAft>
-                <a:spcPts val="200"/>
-              </a:spcAft>
-            </a:pPr>
-            <a:r>
-              <a:rPr sz="1100" b="0">
-                <a:solidFill>
-                  <a:srgbClr val="50B0C0"/>
-                </a:solidFill>
-                <a:latin typeface="Consolas"/>
-              </a:rPr>
-              <a:t>hunger += 0.3/sec  →  seek_chance grows from 45% to 75%</a:t>
-            </a:r>
-          </a:p>
-          <a:p>
-            <a:pPr algn="ctr">
-              <a:spcAft>
-                <a:spcPts val="200"/>
-              </a:spcAft>
-            </a:pPr>
-            <a:r>
-              <a:rPr sz="1100" b="0">
-                <a:solidFill>
-                  <a:srgbClr val="4FDF6F"/>
-                </a:solidFill>
-                <a:latin typeface="Consolas"/>
-              </a:rPr>
-              <a:t>on_eat() resets hunger to 0  →  rival calms down after feeding</a:t>
-            </a:r>
-          </a:p>
-          <a:p>
-            <a:pPr algn="ctr">
-              <a:spcAft>
-                <a:spcPts val="200"/>
-              </a:spcAft>
-            </a:pPr>
-            <a:r>
-              <a:rPr sz="1000" b="0">
-                <a:solidFill>
-                  <a:srgbClr val="888899"/>
-                </a:solidFill>
-                <a:latin typeface="Consolas"/>
-              </a:rPr>
-              <a:t>Effect: starving rivals become aggressive food-seekers</a:t>
-            </a:r>
-          </a:p>
-        </p:txBody>
-      </p:sp>
-      <p:sp>
-        <p:nvSpPr>
-          <p:cNvPr id="16" name="TextBox 15"/>
+              <a:t>         Without it, a faster computer would make the rival get hungry faster!</a:t>
+            </a:r>
+          </a:p>
+        </p:txBody>
+      </p:sp>
+      <p:sp>
+        <p:nvSpPr>
+          <p:cNvPr id="17" name="TextBox 16"/>
           <p:cNvSpPr txBox="1"/>
           <p:nvPr/>
         </p:nvSpPr>
         <p:spPr>
           <a:xfrm>
-            <a:off x="274320" y="6492240"/>
+            <a:off x="274320" y="6537960"/>
             <a:ext cx="10972800" cy="274320"/>
           </a:xfrm>
           <a:prstGeom prst="rect">
@@ -7280,7 +8521,7 @@
                 </a:solidFill>
                 <a:latin typeface="Consolas"/>
               </a:rPr>
-              <a:t>ARKE: Guardians of Earth  |  rival.gd  |  GDScript (Godot 4.2+)  |  Based on CompLaB3D Research</a:t>
+              <a:t>ARKE: Guardians of Earth  |  rival.gd  |  GDScript (Godot 4.x)  |  Based on CompLaB3D Research</a:t>
             </a:r>
           </a:p>
         </p:txBody>

</xml_diff>